<commit_message>
order of fig/tables fixed
</commit_message>
<xml_diff>
--- a/Sororin_mechanism_flowchart.pptx
+++ b/Sororin_mechanism_flowchart.pptx
@@ -5,7 +5,7 @@
     <p:sldMasterId id="2147483648" r:id="rId1"/>
   </p:sldMasterIdLst>
   <p:notesMasterIdLst>
-    <p:notesMasterId r:id="rId10"/>
+    <p:notesMasterId r:id="rId12"/>
   </p:notesMasterIdLst>
   <p:sldIdLst>
     <p:sldId id="256" r:id="rId2"/>
@@ -15,7 +15,9 @@
     <p:sldId id="261" r:id="rId6"/>
     <p:sldId id="262" r:id="rId7"/>
     <p:sldId id="263" r:id="rId8"/>
-    <p:sldId id="260" r:id="rId9"/>
+    <p:sldId id="264" r:id="rId9"/>
+    <p:sldId id="260" r:id="rId10"/>
+    <p:sldId id="265" r:id="rId11"/>
   </p:sldIdLst>
   <p:sldSz cx="12188825" cy="6858000"/>
   <p:notesSz cx="6858000" cy="12188825"/>
@@ -1277,7 +1279,7 @@
         <p:spPr>
           <a:xfrm>
             <a:off x="685800" y="1143000"/>
-            <a:ext cx="5486040" cy="3085920"/>
+            <a:ext cx="5486400" cy="3086100"/>
           </a:xfrm>
           <a:prstGeom prst="rect">
             <a:avLst/>
@@ -1398,7 +1400,7 @@
                 <a:latin typeface="+mn-lt"/>
                 <a:ea typeface="+mn-ea"/>
               </a:rPr>
-              <a:t>8</a:t>
+              <a:t>9</a:t>
             </a:fld>
             <a:endParaRPr lang="en-US" sz="1200" b="0" u="none" strike="noStrike">
               <a:solidFill>
@@ -2474,6 +2476,3239 @@
   <p:clrMapOvr>
     <a:masterClrMapping/>
   </p:clrMapOvr>
+</p:sld>
+</file>
+
+<file path=ppt/slides/slide10.xml><?xml version="1.0" encoding="utf-8"?>
+<p:sld xmlns:a="http://schemas.openxmlformats.org/drawingml/2006/main" xmlns:r="http://schemas.openxmlformats.org/officeDocument/2006/relationships" xmlns:p="http://schemas.openxmlformats.org/presentationml/2006/main">
+  <p:cSld>
+    <p:bg>
+      <p:bgPr>
+        <a:solidFill>
+          <a:srgbClr val="FFFFFF"/>
+        </a:solidFill>
+        <a:effectLst/>
+      </p:bgPr>
+    </p:bg>
+    <p:spTree>
+      <p:nvGrpSpPr>
+        <p:cNvPr id="1" name=""/>
+        <p:cNvGrpSpPr/>
+        <p:nvPr/>
+      </p:nvGrpSpPr>
+      <p:grpSpPr>
+        <a:xfrm>
+          <a:off x="0" y="0"/>
+          <a:ext cx="0" cy="0"/>
+          <a:chOff x="0" y="0"/>
+          <a:chExt cx="0" cy="0"/>
+        </a:xfrm>
+      </p:grpSpPr>
+      <p:sp>
+        <p:nvSpPr>
+          <p:cNvPr id="8" name="Text 0"/>
+          <p:cNvSpPr/>
+          <p:nvPr/>
+        </p:nvSpPr>
+        <p:spPr>
+          <a:xfrm>
+            <a:off x="320040" y="109800"/>
+            <a:ext cx="11521080" cy="411120"/>
+          </a:xfrm>
+          <a:prstGeom prst="rect">
+            <a:avLst/>
+          </a:prstGeom>
+          <a:noFill/>
+          <a:ln w="0">
+            <a:noFill/>
+          </a:ln>
+        </p:spPr>
+        <p:style>
+          <a:lnRef idx="0">
+            <a:scrgbClr r="0" g="0" b="0"/>
+          </a:lnRef>
+          <a:fillRef idx="0">
+            <a:scrgbClr r="0" g="0" b="0"/>
+          </a:fillRef>
+          <a:effectRef idx="0">
+            <a:scrgbClr r="0" g="0" b="0"/>
+          </a:effectRef>
+          <a:fontRef idx="minor"/>
+        </p:style>
+        <p:txBody>
+          <a:bodyPr lIns="90000" tIns="45000" rIns="90000" bIns="45000" anchor="ctr">
+            <a:noAutofit/>
+          </a:bodyPr>
+          <a:lstStyle/>
+          <a:p>
+            <a:pPr algn="ctr" defTabSz="914400">
+              <a:lnSpc>
+                <a:spcPct val="100000"/>
+              </a:lnSpc>
+              <a:tabLst>
+                <a:tab pos="0" algn="l"/>
+              </a:tabLst>
+            </a:pPr>
+            <a:r>
+              <a:rPr lang="en-US" sz="2200" b="1" u="none" strike="noStrike" dirty="0">
+                <a:solidFill>
+                  <a:srgbClr val="2C3E50"/>
+                </a:solidFill>
+                <a:effectLst/>
+                <a:uFillTx/>
+                <a:latin typeface="Cambria"/>
+                <a:ea typeface="Cambria"/>
+              </a:rPr>
+              <a:t>The determinants sit in disorder — the numbers behind the map (Table 3)</a:t>
+            </a:r>
+            <a:endParaRPr lang="en-US" sz="2200" b="0" u="none" strike="noStrike" dirty="0">
+              <a:solidFill>
+                <a:srgbClr val="000000"/>
+              </a:solidFill>
+              <a:effectLst/>
+              <a:uFillTx/>
+              <a:latin typeface="Arial"/>
+            </a:endParaRPr>
+          </a:p>
+        </p:txBody>
+      </p:sp>
+      <p:sp>
+        <p:nvSpPr>
+          <p:cNvPr id="9" name="Text 1"/>
+          <p:cNvSpPr/>
+          <p:nvPr/>
+        </p:nvSpPr>
+        <p:spPr>
+          <a:xfrm>
+            <a:off x="516752" y="4998899"/>
+            <a:ext cx="11155320" cy="1142640"/>
+          </a:xfrm>
+          <a:prstGeom prst="roundRect">
+            <a:avLst>
+              <a:gd name="adj" fmla="val 4800"/>
+            </a:avLst>
+          </a:prstGeom>
+          <a:solidFill>
+            <a:srgbClr val="FCEBD0"/>
+          </a:solidFill>
+          <a:ln w="19050">
+            <a:solidFill>
+              <a:srgbClr val="B9770E"/>
+            </a:solidFill>
+            <a:round/>
+          </a:ln>
+        </p:spPr>
+        <p:style>
+          <a:lnRef idx="0">
+            <a:scrgbClr r="0" g="0" b="0"/>
+          </a:lnRef>
+          <a:fillRef idx="0">
+            <a:scrgbClr r="0" g="0" b="0"/>
+          </a:fillRef>
+          <a:effectRef idx="0">
+            <a:scrgbClr r="0" g="0" b="0"/>
+          </a:effectRef>
+          <a:fontRef idx="minor"/>
+        </p:style>
+        <p:txBody>
+          <a:bodyPr lIns="152280" tIns="152280" rIns="152280" bIns="152280" anchor="ctr">
+            <a:noAutofit/>
+          </a:bodyPr>
+          <a:lstStyle/>
+          <a:p>
+            <a:pPr algn="ctr" defTabSz="914400">
+              <a:lnSpc>
+                <a:spcPct val="100000"/>
+              </a:lnSpc>
+              <a:tabLst>
+                <a:tab pos="0" algn="l"/>
+              </a:tabLst>
+            </a:pPr>
+            <a:r>
+              <a:rPr lang="en-US" sz="1900" b="1" u="none" strike="noStrike" dirty="0">
+                <a:solidFill>
+                  <a:srgbClr val="2C3E50"/>
+                </a:solidFill>
+                <a:effectLst/>
+                <a:uFillTx/>
+                <a:latin typeface="Cambria"/>
+                <a:ea typeface="Cambria"/>
+              </a:rPr>
+              <a:t>Superimposing the experimentally-defined interaction determinants onto the disorder profile revealed that they lie — almost without exception — in </a:t>
+            </a:r>
+            <a:r>
+              <a:rPr lang="en-US" sz="1900" b="1" u="none" strike="noStrike" dirty="0">
+                <a:solidFill>
+                  <a:srgbClr val="B9770E"/>
+                </a:solidFill>
+                <a:effectLst/>
+                <a:uFillTx/>
+                <a:latin typeface="Cambria"/>
+                <a:ea typeface="Cambria"/>
+              </a:rPr>
+              <a:t>disordered segments.</a:t>
+            </a:r>
+            <a:endParaRPr lang="en-US" sz="1900" b="0" u="none" strike="noStrike" dirty="0">
+              <a:solidFill>
+                <a:srgbClr val="000000"/>
+              </a:solidFill>
+              <a:effectLst/>
+              <a:uFillTx/>
+              <a:latin typeface="Arial"/>
+            </a:endParaRPr>
+          </a:p>
+        </p:txBody>
+      </p:sp>
+      <p:graphicFrame>
+        <p:nvGraphicFramePr>
+          <p:cNvPr id="10" name="Table 0"/>
+          <p:cNvGraphicFramePr/>
+          <p:nvPr>
+            <p:extLst>
+              <p:ext uri="{D42A27DB-BD31-4B8C-83A1-F6EECF244321}">
+                <p14:modId xmlns:p14="http://schemas.microsoft.com/office/powerpoint/2010/main" val="984274293"/>
+              </p:ext>
+            </p:extLst>
+          </p:nvPr>
+        </p:nvGraphicFramePr>
+        <p:xfrm>
+          <a:off x="502200" y="991632"/>
+          <a:ext cx="11155680" cy="2174760"/>
+        </p:xfrm>
+        <a:graphic>
+          <a:graphicData uri="http://schemas.openxmlformats.org/drawingml/2006/table">
+            <a:tbl>
+              <a:tblPr/>
+              <a:tblGrid>
+                <a:gridCol w="2011680">
+                  <a:extLst>
+                    <a:ext uri="{9D8B030D-6E8A-4147-A177-3AD203B41FA5}">
+                      <a16:colId xmlns:a16="http://schemas.microsoft.com/office/drawing/2014/main" val="20000"/>
+                    </a:ext>
+                  </a:extLst>
+                </a:gridCol>
+                <a:gridCol w="1188720">
+                  <a:extLst>
+                    <a:ext uri="{9D8B030D-6E8A-4147-A177-3AD203B41FA5}">
+                      <a16:colId xmlns:a16="http://schemas.microsoft.com/office/drawing/2014/main" val="20001"/>
+                    </a:ext>
+                  </a:extLst>
+                </a:gridCol>
+                <a:gridCol w="2834640">
+                  <a:extLst>
+                    <a:ext uri="{9D8B030D-6E8A-4147-A177-3AD203B41FA5}">
+                      <a16:colId xmlns:a16="http://schemas.microsoft.com/office/drawing/2014/main" val="20002"/>
+                    </a:ext>
+                  </a:extLst>
+                </a:gridCol>
+                <a:gridCol w="2286000">
+                  <a:extLst>
+                    <a:ext uri="{9D8B030D-6E8A-4147-A177-3AD203B41FA5}">
+                      <a16:colId xmlns:a16="http://schemas.microsoft.com/office/drawing/2014/main" val="20003"/>
+                    </a:ext>
+                  </a:extLst>
+                </a:gridCol>
+                <a:gridCol w="2834640">
+                  <a:extLst>
+                    <a:ext uri="{9D8B030D-6E8A-4147-A177-3AD203B41FA5}">
+                      <a16:colId xmlns:a16="http://schemas.microsoft.com/office/drawing/2014/main" val="20004"/>
+                    </a:ext>
+                  </a:extLst>
+                </a:gridCol>
+              </a:tblGrid>
+              <a:tr h="310680">
+                <a:tc>
+                  <a:txBody>
+                    <a:bodyPr/>
+                    <a:lstStyle/>
+                    <a:p>
+                      <a:pPr defTabSz="914400">
+                        <a:lnSpc>
+                          <a:spcPct val="100000"/>
+                        </a:lnSpc>
+                        <a:tabLst>
+                          <a:tab pos="0" algn="l"/>
+                        </a:tabLst>
+                      </a:pPr>
+                      <a:r>
+                        <a:rPr lang="en-US" sz="1200" b="1" u="none" strike="noStrike">
+                          <a:solidFill>
+                            <a:srgbClr val="FFFFFF"/>
+                          </a:solidFill>
+                          <a:effectLst/>
+                          <a:uFillTx/>
+                          <a:latin typeface="Calibri"/>
+                          <a:ea typeface="Calibri"/>
+                        </a:rPr>
+                        <a:t>Determinant</a:t>
+                      </a:r>
+                      <a:endParaRPr lang="en-US" sz="1200" b="0" u="none" strike="noStrike">
+                        <a:solidFill>
+                          <a:srgbClr val="FFFFFF"/>
+                        </a:solidFill>
+                        <a:effectLst/>
+                        <a:uFillTx/>
+                        <a:latin typeface="Arial"/>
+                      </a:endParaRPr>
+                    </a:p>
+                  </a:txBody>
+                  <a:tcPr anchor="ctr">
+                    <a:lnL w="6480">
+                      <a:solidFill>
+                        <a:srgbClr val="CFCFCF"/>
+                      </a:solidFill>
+                      <a:prstDash val="solid"/>
+                    </a:lnL>
+                    <a:lnR w="6480">
+                      <a:solidFill>
+                        <a:srgbClr val="CFCFCF"/>
+                      </a:solidFill>
+                      <a:prstDash val="solid"/>
+                    </a:lnR>
+                    <a:lnT w="6480">
+                      <a:solidFill>
+                        <a:srgbClr val="CFCFCF"/>
+                      </a:solidFill>
+                      <a:prstDash val="solid"/>
+                    </a:lnT>
+                    <a:lnB w="6480">
+                      <a:solidFill>
+                        <a:srgbClr val="CFCFCF"/>
+                      </a:solidFill>
+                      <a:prstDash val="solid"/>
+                    </a:lnB>
+                    <a:solidFill>
+                      <a:srgbClr val="2C3E50"/>
+                    </a:solidFill>
+                  </a:tcPr>
+                </a:tc>
+                <a:tc>
+                  <a:txBody>
+                    <a:bodyPr/>
+                    <a:lstStyle/>
+                    <a:p>
+                      <a:pPr defTabSz="914400">
+                        <a:lnSpc>
+                          <a:spcPct val="100000"/>
+                        </a:lnSpc>
+                        <a:tabLst>
+                          <a:tab pos="0" algn="l"/>
+                        </a:tabLst>
+                      </a:pPr>
+                      <a:r>
+                        <a:rPr lang="en-US" sz="1200" b="1" u="none" strike="noStrike">
+                          <a:solidFill>
+                            <a:srgbClr val="FFFFFF"/>
+                          </a:solidFill>
+                          <a:effectLst/>
+                          <a:uFillTx/>
+                          <a:latin typeface="Calibri"/>
+                          <a:ea typeface="Calibri"/>
+                        </a:rPr>
+                        <a:t>Residues</a:t>
+                      </a:r>
+                      <a:endParaRPr lang="en-US" sz="1200" b="0" u="none" strike="noStrike">
+                        <a:solidFill>
+                          <a:srgbClr val="FFFFFF"/>
+                        </a:solidFill>
+                        <a:effectLst/>
+                        <a:uFillTx/>
+                        <a:latin typeface="Arial"/>
+                      </a:endParaRPr>
+                    </a:p>
+                  </a:txBody>
+                  <a:tcPr anchor="ctr">
+                    <a:lnL w="6480">
+                      <a:solidFill>
+                        <a:srgbClr val="CFCFCF"/>
+                      </a:solidFill>
+                      <a:prstDash val="solid"/>
+                    </a:lnL>
+                    <a:lnR w="6480">
+                      <a:solidFill>
+                        <a:srgbClr val="CFCFCF"/>
+                      </a:solidFill>
+                      <a:prstDash val="solid"/>
+                    </a:lnR>
+                    <a:lnT w="6480">
+                      <a:solidFill>
+                        <a:srgbClr val="CFCFCF"/>
+                      </a:solidFill>
+                      <a:prstDash val="solid"/>
+                    </a:lnT>
+                    <a:lnB w="6480">
+                      <a:solidFill>
+                        <a:srgbClr val="CFCFCF"/>
+                      </a:solidFill>
+                      <a:prstDash val="solid"/>
+                    </a:lnB>
+                    <a:solidFill>
+                      <a:srgbClr val="2C3E50"/>
+                    </a:solidFill>
+                  </a:tcPr>
+                </a:tc>
+                <a:tc>
+                  <a:txBody>
+                    <a:bodyPr/>
+                    <a:lstStyle/>
+                    <a:p>
+                      <a:pPr defTabSz="914400">
+                        <a:lnSpc>
+                          <a:spcPct val="100000"/>
+                        </a:lnSpc>
+                        <a:tabLst>
+                          <a:tab pos="0" algn="l"/>
+                        </a:tabLst>
+                      </a:pPr>
+                      <a:r>
+                        <a:rPr lang="en-US" sz="1200" b="1" u="none" strike="noStrike" dirty="0">
+                          <a:solidFill>
+                            <a:srgbClr val="FFFFFF"/>
+                          </a:solidFill>
+                          <a:effectLst/>
+                          <a:uFillTx/>
+                          <a:latin typeface="Calibri"/>
+                          <a:ea typeface="Calibri"/>
+                        </a:rPr>
+                        <a:t>Partner / role</a:t>
+                      </a:r>
+                      <a:endParaRPr lang="en-US" sz="1200" b="0" u="none" strike="noStrike" dirty="0">
+                        <a:solidFill>
+                          <a:srgbClr val="FFFFFF"/>
+                        </a:solidFill>
+                        <a:effectLst/>
+                        <a:uFillTx/>
+                        <a:latin typeface="Arial"/>
+                      </a:endParaRPr>
+                    </a:p>
+                  </a:txBody>
+                  <a:tcPr anchor="ctr">
+                    <a:lnL w="6480">
+                      <a:solidFill>
+                        <a:srgbClr val="CFCFCF"/>
+                      </a:solidFill>
+                      <a:prstDash val="solid"/>
+                    </a:lnL>
+                    <a:lnR w="6480">
+                      <a:solidFill>
+                        <a:srgbClr val="CFCFCF"/>
+                      </a:solidFill>
+                      <a:prstDash val="solid"/>
+                    </a:lnR>
+                    <a:lnT w="6480">
+                      <a:solidFill>
+                        <a:srgbClr val="CFCFCF"/>
+                      </a:solidFill>
+                      <a:prstDash val="solid"/>
+                    </a:lnT>
+                    <a:lnB w="6480">
+                      <a:solidFill>
+                        <a:srgbClr val="CFCFCF"/>
+                      </a:solidFill>
+                      <a:prstDash val="solid"/>
+                    </a:lnB>
+                    <a:solidFill>
+                      <a:srgbClr val="2C3E50"/>
+                    </a:solidFill>
+                  </a:tcPr>
+                </a:tc>
+                <a:tc>
+                  <a:txBody>
+                    <a:bodyPr/>
+                    <a:lstStyle/>
+                    <a:p>
+                      <a:pPr defTabSz="914400">
+                        <a:lnSpc>
+                          <a:spcPct val="100000"/>
+                        </a:lnSpc>
+                        <a:tabLst>
+                          <a:tab pos="0" algn="l"/>
+                        </a:tabLst>
+                      </a:pPr>
+                      <a:r>
+                        <a:rPr lang="en-US" sz="1200" b="1" u="none" strike="noStrike">
+                          <a:solidFill>
+                            <a:srgbClr val="FFFFFF"/>
+                          </a:solidFill>
+                          <a:effectLst/>
+                          <a:uFillTx/>
+                          <a:latin typeface="Calibri"/>
+                          <a:ea typeface="Calibri"/>
+                        </a:rPr>
+                        <a:t>Mean IUPred2 (% dis.)</a:t>
+                      </a:r>
+                      <a:endParaRPr lang="en-US" sz="1200" b="0" u="none" strike="noStrike">
+                        <a:solidFill>
+                          <a:srgbClr val="FFFFFF"/>
+                        </a:solidFill>
+                        <a:effectLst/>
+                        <a:uFillTx/>
+                        <a:latin typeface="Arial"/>
+                      </a:endParaRPr>
+                    </a:p>
+                  </a:txBody>
+                  <a:tcPr anchor="ctr">
+                    <a:lnL w="6480">
+                      <a:solidFill>
+                        <a:srgbClr val="CFCFCF"/>
+                      </a:solidFill>
+                      <a:prstDash val="solid"/>
+                    </a:lnL>
+                    <a:lnR w="6480">
+                      <a:solidFill>
+                        <a:srgbClr val="CFCFCF"/>
+                      </a:solidFill>
+                      <a:prstDash val="solid"/>
+                    </a:lnR>
+                    <a:lnT w="6480">
+                      <a:solidFill>
+                        <a:srgbClr val="CFCFCF"/>
+                      </a:solidFill>
+                      <a:prstDash val="solid"/>
+                    </a:lnT>
+                    <a:lnB w="6480">
+                      <a:solidFill>
+                        <a:srgbClr val="CFCFCF"/>
+                      </a:solidFill>
+                      <a:prstDash val="solid"/>
+                    </a:lnB>
+                    <a:solidFill>
+                      <a:srgbClr val="2C3E50"/>
+                    </a:solidFill>
+                  </a:tcPr>
+                </a:tc>
+                <a:tc>
+                  <a:txBody>
+                    <a:bodyPr/>
+                    <a:lstStyle/>
+                    <a:p>
+                      <a:pPr defTabSz="914400">
+                        <a:lnSpc>
+                          <a:spcPct val="100000"/>
+                        </a:lnSpc>
+                        <a:tabLst>
+                          <a:tab pos="0" algn="l"/>
+                        </a:tabLst>
+                      </a:pPr>
+                      <a:r>
+                        <a:rPr lang="en-US" sz="1200" b="1" u="none" strike="noStrike">
+                          <a:solidFill>
+                            <a:srgbClr val="FFFFFF"/>
+                          </a:solidFill>
+                          <a:effectLst/>
+                          <a:uFillTx/>
+                          <a:latin typeface="Calibri"/>
+                          <a:ea typeface="Calibri"/>
+                        </a:rPr>
+                        <a:t>Structural context</a:t>
+                      </a:r>
+                      <a:endParaRPr lang="en-US" sz="1200" b="0" u="none" strike="noStrike">
+                        <a:solidFill>
+                          <a:srgbClr val="FFFFFF"/>
+                        </a:solidFill>
+                        <a:effectLst/>
+                        <a:uFillTx/>
+                        <a:latin typeface="Arial"/>
+                      </a:endParaRPr>
+                    </a:p>
+                  </a:txBody>
+                  <a:tcPr anchor="ctr">
+                    <a:lnL w="6480">
+                      <a:solidFill>
+                        <a:srgbClr val="CFCFCF"/>
+                      </a:solidFill>
+                      <a:prstDash val="solid"/>
+                    </a:lnL>
+                    <a:lnR w="6480">
+                      <a:solidFill>
+                        <a:srgbClr val="CFCFCF"/>
+                      </a:solidFill>
+                      <a:prstDash val="solid"/>
+                    </a:lnR>
+                    <a:lnT w="6480">
+                      <a:solidFill>
+                        <a:srgbClr val="CFCFCF"/>
+                      </a:solidFill>
+                      <a:prstDash val="solid"/>
+                    </a:lnT>
+                    <a:lnB w="6480">
+                      <a:solidFill>
+                        <a:srgbClr val="CFCFCF"/>
+                      </a:solidFill>
+                      <a:prstDash val="solid"/>
+                    </a:lnB>
+                    <a:solidFill>
+                      <a:srgbClr val="2C3E50"/>
+                    </a:solidFill>
+                  </a:tcPr>
+                </a:tc>
+                <a:extLst>
+                  <a:ext uri="{0D108BD9-81ED-4DB2-BD59-A6C34878D82A}">
+                    <a16:rowId xmlns:a16="http://schemas.microsoft.com/office/drawing/2014/main" val="10000"/>
+                  </a:ext>
+                </a:extLst>
+              </a:tr>
+              <a:tr h="310680">
+                <a:tc>
+                  <a:txBody>
+                    <a:bodyPr/>
+                    <a:lstStyle/>
+                    <a:p>
+                      <a:pPr defTabSz="914400">
+                        <a:lnSpc>
+                          <a:spcPct val="100000"/>
+                        </a:lnSpc>
+                        <a:tabLst>
+                          <a:tab pos="0" algn="l"/>
+                        </a:tabLst>
+                      </a:pPr>
+                      <a:r>
+                        <a:rPr lang="en-US" sz="1200" b="1" u="none" strike="noStrike">
+                          <a:solidFill>
+                            <a:srgbClr val="2C3E50"/>
+                          </a:solidFill>
+                          <a:effectLst/>
+                          <a:uFillTx/>
+                          <a:latin typeface="Calibri"/>
+                          <a:ea typeface="Calibri"/>
+                        </a:rPr>
+                        <a:t>N-terminal IDR</a:t>
+                      </a:r>
+                      <a:endParaRPr lang="en-US" sz="1200" b="0" u="none" strike="noStrike">
+                        <a:solidFill>
+                          <a:srgbClr val="000000"/>
+                        </a:solidFill>
+                        <a:effectLst/>
+                        <a:uFillTx/>
+                        <a:latin typeface="Arial"/>
+                      </a:endParaRPr>
+                    </a:p>
+                  </a:txBody>
+                  <a:tcPr anchor="ctr">
+                    <a:lnL w="6480">
+                      <a:solidFill>
+                        <a:srgbClr val="CFCFCF"/>
+                      </a:solidFill>
+                      <a:prstDash val="solid"/>
+                    </a:lnL>
+                    <a:lnR w="6480">
+                      <a:solidFill>
+                        <a:srgbClr val="CFCFCF"/>
+                      </a:solidFill>
+                      <a:prstDash val="solid"/>
+                    </a:lnR>
+                    <a:lnT w="6480">
+                      <a:solidFill>
+                        <a:srgbClr val="CFCFCF"/>
+                      </a:solidFill>
+                      <a:prstDash val="solid"/>
+                    </a:lnT>
+                    <a:lnB w="6480">
+                      <a:solidFill>
+                        <a:srgbClr val="CFCFCF"/>
+                      </a:solidFill>
+                      <a:prstDash val="solid"/>
+                    </a:lnB>
+                    <a:noFill/>
+                  </a:tcPr>
+                </a:tc>
+                <a:tc>
+                  <a:txBody>
+                    <a:bodyPr/>
+                    <a:lstStyle/>
+                    <a:p>
+                      <a:pPr defTabSz="914400">
+                        <a:lnSpc>
+                          <a:spcPct val="100000"/>
+                        </a:lnSpc>
+                        <a:tabLst>
+                          <a:tab pos="0" algn="l"/>
+                        </a:tabLst>
+                      </a:pPr>
+                      <a:r>
+                        <a:rPr lang="en-US" sz="1200" b="0" u="none" strike="noStrike">
+                          <a:solidFill>
+                            <a:srgbClr val="2C3E50"/>
+                          </a:solidFill>
+                          <a:effectLst/>
+                          <a:uFillTx/>
+                          <a:latin typeface="Calibri"/>
+                          <a:ea typeface="Calibri"/>
+                        </a:rPr>
+                        <a:t>1–48</a:t>
+                      </a:r>
+                      <a:endParaRPr lang="en-US" sz="1200" b="0" u="none" strike="noStrike">
+                        <a:solidFill>
+                          <a:srgbClr val="000000"/>
+                        </a:solidFill>
+                        <a:effectLst/>
+                        <a:uFillTx/>
+                        <a:latin typeface="Arial"/>
+                      </a:endParaRPr>
+                    </a:p>
+                  </a:txBody>
+                  <a:tcPr anchor="ctr">
+                    <a:lnL w="6480">
+                      <a:solidFill>
+                        <a:srgbClr val="CFCFCF"/>
+                      </a:solidFill>
+                      <a:prstDash val="solid"/>
+                    </a:lnL>
+                    <a:lnR w="6480">
+                      <a:solidFill>
+                        <a:srgbClr val="CFCFCF"/>
+                      </a:solidFill>
+                      <a:prstDash val="solid"/>
+                    </a:lnR>
+                    <a:lnT w="6480">
+                      <a:solidFill>
+                        <a:srgbClr val="CFCFCF"/>
+                      </a:solidFill>
+                      <a:prstDash val="solid"/>
+                    </a:lnT>
+                    <a:lnB w="6480">
+                      <a:solidFill>
+                        <a:srgbClr val="CFCFCF"/>
+                      </a:solidFill>
+                      <a:prstDash val="solid"/>
+                    </a:lnB>
+                    <a:noFill/>
+                  </a:tcPr>
+                </a:tc>
+                <a:tc>
+                  <a:txBody>
+                    <a:bodyPr/>
+                    <a:lstStyle/>
+                    <a:p>
+                      <a:pPr defTabSz="914400">
+                        <a:lnSpc>
+                          <a:spcPct val="100000"/>
+                        </a:lnSpc>
+                        <a:tabLst>
+                          <a:tab pos="0" algn="l"/>
+                        </a:tabLst>
+                      </a:pPr>
+                      <a:r>
+                        <a:rPr lang="en-US" sz="1200" b="0" u="none" strike="noStrike">
+                          <a:solidFill>
+                            <a:srgbClr val="2C3E50"/>
+                          </a:solidFill>
+                          <a:effectLst/>
+                          <a:uFillTx/>
+                          <a:latin typeface="Calibri"/>
+                          <a:ea typeface="Calibri"/>
+                        </a:rPr>
+                        <a:t>loading / regulation</a:t>
+                      </a:r>
+                      <a:endParaRPr lang="en-US" sz="1200" b="0" u="none" strike="noStrike">
+                        <a:solidFill>
+                          <a:srgbClr val="000000"/>
+                        </a:solidFill>
+                        <a:effectLst/>
+                        <a:uFillTx/>
+                        <a:latin typeface="Arial"/>
+                      </a:endParaRPr>
+                    </a:p>
+                  </a:txBody>
+                  <a:tcPr anchor="ctr">
+                    <a:lnL w="6480">
+                      <a:solidFill>
+                        <a:srgbClr val="CFCFCF"/>
+                      </a:solidFill>
+                      <a:prstDash val="solid"/>
+                    </a:lnL>
+                    <a:lnR w="6480">
+                      <a:solidFill>
+                        <a:srgbClr val="CFCFCF"/>
+                      </a:solidFill>
+                      <a:prstDash val="solid"/>
+                    </a:lnR>
+                    <a:lnT w="6480">
+                      <a:solidFill>
+                        <a:srgbClr val="CFCFCF"/>
+                      </a:solidFill>
+                      <a:prstDash val="solid"/>
+                    </a:lnT>
+                    <a:lnB w="6480">
+                      <a:solidFill>
+                        <a:srgbClr val="CFCFCF"/>
+                      </a:solidFill>
+                      <a:prstDash val="solid"/>
+                    </a:lnB>
+                    <a:noFill/>
+                  </a:tcPr>
+                </a:tc>
+                <a:tc>
+                  <a:txBody>
+                    <a:bodyPr/>
+                    <a:lstStyle/>
+                    <a:p>
+                      <a:pPr defTabSz="914400">
+                        <a:lnSpc>
+                          <a:spcPct val="100000"/>
+                        </a:lnSpc>
+                        <a:tabLst>
+                          <a:tab pos="0" algn="l"/>
+                        </a:tabLst>
+                      </a:pPr>
+                      <a:r>
+                        <a:rPr lang="en-US" sz="1200" b="0" u="none" strike="noStrike">
+                          <a:solidFill>
+                            <a:srgbClr val="2C3E50"/>
+                          </a:solidFill>
+                          <a:effectLst/>
+                          <a:uFillTx/>
+                          <a:latin typeface="Calibri"/>
+                          <a:ea typeface="Calibri"/>
+                        </a:rPr>
+                        <a:t>0.82  (100%)</a:t>
+                      </a:r>
+                      <a:endParaRPr lang="en-US" sz="1200" b="0" u="none" strike="noStrike">
+                        <a:solidFill>
+                          <a:srgbClr val="000000"/>
+                        </a:solidFill>
+                        <a:effectLst/>
+                        <a:uFillTx/>
+                        <a:latin typeface="Arial"/>
+                      </a:endParaRPr>
+                    </a:p>
+                  </a:txBody>
+                  <a:tcPr anchor="ctr">
+                    <a:lnL w="6480">
+                      <a:solidFill>
+                        <a:srgbClr val="CFCFCF"/>
+                      </a:solidFill>
+                      <a:prstDash val="solid"/>
+                    </a:lnL>
+                    <a:lnR w="6480">
+                      <a:solidFill>
+                        <a:srgbClr val="CFCFCF"/>
+                      </a:solidFill>
+                      <a:prstDash val="solid"/>
+                    </a:lnR>
+                    <a:lnT w="6480">
+                      <a:solidFill>
+                        <a:srgbClr val="CFCFCF"/>
+                      </a:solidFill>
+                      <a:prstDash val="solid"/>
+                    </a:lnT>
+                    <a:lnB w="6480">
+                      <a:solidFill>
+                        <a:srgbClr val="CFCFCF"/>
+                      </a:solidFill>
+                      <a:prstDash val="solid"/>
+                    </a:lnB>
+                    <a:noFill/>
+                  </a:tcPr>
+                </a:tc>
+                <a:tc>
+                  <a:txBody>
+                    <a:bodyPr/>
+                    <a:lstStyle/>
+                    <a:p>
+                      <a:pPr defTabSz="914400">
+                        <a:lnSpc>
+                          <a:spcPct val="100000"/>
+                        </a:lnSpc>
+                        <a:tabLst>
+                          <a:tab pos="0" algn="l"/>
+                        </a:tabLst>
+                      </a:pPr>
+                      <a:r>
+                        <a:rPr lang="en-US" sz="1200" b="0" i="1" u="none" strike="noStrike">
+                          <a:solidFill>
+                            <a:srgbClr val="2C3E50"/>
+                          </a:solidFill>
+                          <a:effectLst/>
+                          <a:uFillTx/>
+                          <a:latin typeface="Calibri"/>
+                          <a:ea typeface="Calibri"/>
+                        </a:rPr>
+                        <a:t>disordered</a:t>
+                      </a:r>
+                      <a:endParaRPr lang="en-US" sz="1200" b="0" u="none" strike="noStrike">
+                        <a:solidFill>
+                          <a:srgbClr val="000000"/>
+                        </a:solidFill>
+                        <a:effectLst/>
+                        <a:uFillTx/>
+                        <a:latin typeface="Arial"/>
+                      </a:endParaRPr>
+                    </a:p>
+                  </a:txBody>
+                  <a:tcPr anchor="ctr">
+                    <a:lnL w="6480">
+                      <a:solidFill>
+                        <a:srgbClr val="CFCFCF"/>
+                      </a:solidFill>
+                      <a:prstDash val="solid"/>
+                    </a:lnL>
+                    <a:lnR w="6480">
+                      <a:solidFill>
+                        <a:srgbClr val="CFCFCF"/>
+                      </a:solidFill>
+                      <a:prstDash val="solid"/>
+                    </a:lnR>
+                    <a:lnT w="6480">
+                      <a:solidFill>
+                        <a:srgbClr val="CFCFCF"/>
+                      </a:solidFill>
+                      <a:prstDash val="solid"/>
+                    </a:lnT>
+                    <a:lnB w="6480">
+                      <a:solidFill>
+                        <a:srgbClr val="CFCFCF"/>
+                      </a:solidFill>
+                      <a:prstDash val="solid"/>
+                    </a:lnB>
+                    <a:noFill/>
+                  </a:tcPr>
+                </a:tc>
+                <a:extLst>
+                  <a:ext uri="{0D108BD9-81ED-4DB2-BD59-A6C34878D82A}">
+                    <a16:rowId xmlns:a16="http://schemas.microsoft.com/office/drawing/2014/main" val="10001"/>
+                  </a:ext>
+                </a:extLst>
+              </a:tr>
+              <a:tr h="310680">
+                <a:tc>
+                  <a:txBody>
+                    <a:bodyPr/>
+                    <a:lstStyle/>
+                    <a:p>
+                      <a:pPr defTabSz="914400">
+                        <a:lnSpc>
+                          <a:spcPct val="100000"/>
+                        </a:lnSpc>
+                        <a:tabLst>
+                          <a:tab pos="0" algn="l"/>
+                        </a:tabLst>
+                      </a:pPr>
+                      <a:r>
+                        <a:rPr lang="en-US" sz="1200" b="1" u="none" strike="noStrike">
+                          <a:solidFill>
+                            <a:srgbClr val="2C3E50"/>
+                          </a:solidFill>
+                          <a:effectLst/>
+                          <a:uFillTx/>
+                          <a:latin typeface="Calibri"/>
+                          <a:ea typeface="Calibri"/>
+                        </a:rPr>
+                        <a:t>KEN box</a:t>
+                      </a:r>
+                      <a:endParaRPr lang="en-US" sz="1200" b="0" u="none" strike="noStrike">
+                        <a:solidFill>
+                          <a:srgbClr val="000000"/>
+                        </a:solidFill>
+                        <a:effectLst/>
+                        <a:uFillTx/>
+                        <a:latin typeface="Arial"/>
+                      </a:endParaRPr>
+                    </a:p>
+                  </a:txBody>
+                  <a:tcPr anchor="ctr">
+                    <a:lnL w="6480">
+                      <a:solidFill>
+                        <a:srgbClr val="CFCFCF"/>
+                      </a:solidFill>
+                      <a:prstDash val="solid"/>
+                    </a:lnL>
+                    <a:lnR w="6480">
+                      <a:solidFill>
+                        <a:srgbClr val="CFCFCF"/>
+                      </a:solidFill>
+                      <a:prstDash val="solid"/>
+                    </a:lnR>
+                    <a:lnT w="6480">
+                      <a:solidFill>
+                        <a:srgbClr val="CFCFCF"/>
+                      </a:solidFill>
+                      <a:prstDash val="solid"/>
+                    </a:lnT>
+                    <a:lnB w="6480">
+                      <a:solidFill>
+                        <a:srgbClr val="CFCFCF"/>
+                      </a:solidFill>
+                      <a:prstDash val="solid"/>
+                    </a:lnB>
+                    <a:noFill/>
+                  </a:tcPr>
+                </a:tc>
+                <a:tc>
+                  <a:txBody>
+                    <a:bodyPr/>
+                    <a:lstStyle/>
+                    <a:p>
+                      <a:pPr defTabSz="914400">
+                        <a:lnSpc>
+                          <a:spcPct val="100000"/>
+                        </a:lnSpc>
+                        <a:tabLst>
+                          <a:tab pos="0" algn="l"/>
+                        </a:tabLst>
+                      </a:pPr>
+                      <a:r>
+                        <a:rPr lang="en-US" sz="1200" b="0" u="none" strike="noStrike">
+                          <a:solidFill>
+                            <a:srgbClr val="2C3E50"/>
+                          </a:solidFill>
+                          <a:effectLst/>
+                          <a:uFillTx/>
+                          <a:latin typeface="Calibri"/>
+                          <a:ea typeface="Calibri"/>
+                        </a:rPr>
+                        <a:t>88–90</a:t>
+                      </a:r>
+                      <a:endParaRPr lang="en-US" sz="1200" b="0" u="none" strike="noStrike">
+                        <a:solidFill>
+                          <a:srgbClr val="000000"/>
+                        </a:solidFill>
+                        <a:effectLst/>
+                        <a:uFillTx/>
+                        <a:latin typeface="Arial"/>
+                      </a:endParaRPr>
+                    </a:p>
+                  </a:txBody>
+                  <a:tcPr anchor="ctr">
+                    <a:lnL w="6480">
+                      <a:solidFill>
+                        <a:srgbClr val="CFCFCF"/>
+                      </a:solidFill>
+                      <a:prstDash val="solid"/>
+                    </a:lnL>
+                    <a:lnR w="6480">
+                      <a:solidFill>
+                        <a:srgbClr val="CFCFCF"/>
+                      </a:solidFill>
+                      <a:prstDash val="solid"/>
+                    </a:lnR>
+                    <a:lnT w="6480">
+                      <a:solidFill>
+                        <a:srgbClr val="CFCFCF"/>
+                      </a:solidFill>
+                      <a:prstDash val="solid"/>
+                    </a:lnT>
+                    <a:lnB w="6480">
+                      <a:solidFill>
+                        <a:srgbClr val="CFCFCF"/>
+                      </a:solidFill>
+                      <a:prstDash val="solid"/>
+                    </a:lnB>
+                    <a:noFill/>
+                  </a:tcPr>
+                </a:tc>
+                <a:tc>
+                  <a:txBody>
+                    <a:bodyPr/>
+                    <a:lstStyle/>
+                    <a:p>
+                      <a:pPr defTabSz="914400">
+                        <a:lnSpc>
+                          <a:spcPct val="100000"/>
+                        </a:lnSpc>
+                        <a:tabLst>
+                          <a:tab pos="0" algn="l"/>
+                        </a:tabLst>
+                      </a:pPr>
+                      <a:r>
+                        <a:rPr lang="en-US" sz="1200" b="0" u="none" strike="noStrike">
+                          <a:solidFill>
+                            <a:srgbClr val="2C3E50"/>
+                          </a:solidFill>
+                          <a:effectLst/>
+                          <a:uFillTx/>
+                          <a:latin typeface="Calibri"/>
+                          <a:ea typeface="Calibri"/>
+                        </a:rPr>
+                        <a:t>APC/C (degradation)</a:t>
+                      </a:r>
+                      <a:endParaRPr lang="en-US" sz="1200" b="0" u="none" strike="noStrike">
+                        <a:solidFill>
+                          <a:srgbClr val="000000"/>
+                        </a:solidFill>
+                        <a:effectLst/>
+                        <a:uFillTx/>
+                        <a:latin typeface="Arial"/>
+                      </a:endParaRPr>
+                    </a:p>
+                  </a:txBody>
+                  <a:tcPr anchor="ctr">
+                    <a:lnL w="6480">
+                      <a:solidFill>
+                        <a:srgbClr val="CFCFCF"/>
+                      </a:solidFill>
+                      <a:prstDash val="solid"/>
+                    </a:lnL>
+                    <a:lnR w="6480">
+                      <a:solidFill>
+                        <a:srgbClr val="CFCFCF"/>
+                      </a:solidFill>
+                      <a:prstDash val="solid"/>
+                    </a:lnR>
+                    <a:lnT w="6480">
+                      <a:solidFill>
+                        <a:srgbClr val="CFCFCF"/>
+                      </a:solidFill>
+                      <a:prstDash val="solid"/>
+                    </a:lnT>
+                    <a:lnB w="6480">
+                      <a:solidFill>
+                        <a:srgbClr val="CFCFCF"/>
+                      </a:solidFill>
+                      <a:prstDash val="solid"/>
+                    </a:lnB>
+                    <a:noFill/>
+                  </a:tcPr>
+                </a:tc>
+                <a:tc>
+                  <a:txBody>
+                    <a:bodyPr/>
+                    <a:lstStyle/>
+                    <a:p>
+                      <a:pPr defTabSz="914400">
+                        <a:lnSpc>
+                          <a:spcPct val="100000"/>
+                        </a:lnSpc>
+                        <a:tabLst>
+                          <a:tab pos="0" algn="l"/>
+                        </a:tabLst>
+                      </a:pPr>
+                      <a:r>
+                        <a:rPr lang="en-US" sz="1200" b="0" u="none" strike="noStrike">
+                          <a:solidFill>
+                            <a:srgbClr val="2C3E50"/>
+                          </a:solidFill>
+                          <a:effectLst/>
+                          <a:uFillTx/>
+                          <a:latin typeface="Calibri"/>
+                          <a:ea typeface="Calibri"/>
+                        </a:rPr>
+                        <a:t>0.64  (100%)</a:t>
+                      </a:r>
+                      <a:endParaRPr lang="en-US" sz="1200" b="0" u="none" strike="noStrike">
+                        <a:solidFill>
+                          <a:srgbClr val="000000"/>
+                        </a:solidFill>
+                        <a:effectLst/>
+                        <a:uFillTx/>
+                        <a:latin typeface="Arial"/>
+                      </a:endParaRPr>
+                    </a:p>
+                  </a:txBody>
+                  <a:tcPr anchor="ctr">
+                    <a:lnL w="6480">
+                      <a:solidFill>
+                        <a:srgbClr val="CFCFCF"/>
+                      </a:solidFill>
+                      <a:prstDash val="solid"/>
+                    </a:lnL>
+                    <a:lnR w="6480">
+                      <a:solidFill>
+                        <a:srgbClr val="CFCFCF"/>
+                      </a:solidFill>
+                      <a:prstDash val="solid"/>
+                    </a:lnR>
+                    <a:lnT w="6480">
+                      <a:solidFill>
+                        <a:srgbClr val="CFCFCF"/>
+                      </a:solidFill>
+                      <a:prstDash val="solid"/>
+                    </a:lnT>
+                    <a:lnB w="6480">
+                      <a:solidFill>
+                        <a:srgbClr val="CFCFCF"/>
+                      </a:solidFill>
+                      <a:prstDash val="solid"/>
+                    </a:lnB>
+                    <a:noFill/>
+                  </a:tcPr>
+                </a:tc>
+                <a:tc>
+                  <a:txBody>
+                    <a:bodyPr/>
+                    <a:lstStyle/>
+                    <a:p>
+                      <a:pPr defTabSz="914400">
+                        <a:lnSpc>
+                          <a:spcPct val="100000"/>
+                        </a:lnSpc>
+                        <a:tabLst>
+                          <a:tab pos="0" algn="l"/>
+                        </a:tabLst>
+                      </a:pPr>
+                      <a:r>
+                        <a:rPr lang="en-US" sz="1200" b="0" i="1" u="none" strike="noStrike">
+                          <a:solidFill>
+                            <a:srgbClr val="2C3E50"/>
+                          </a:solidFill>
+                          <a:effectLst/>
+                          <a:uFillTx/>
+                          <a:latin typeface="Calibri"/>
+                          <a:ea typeface="Calibri"/>
+                        </a:rPr>
+                        <a:t>disordered</a:t>
+                      </a:r>
+                      <a:endParaRPr lang="en-US" sz="1200" b="0" u="none" strike="noStrike">
+                        <a:solidFill>
+                          <a:srgbClr val="000000"/>
+                        </a:solidFill>
+                        <a:effectLst/>
+                        <a:uFillTx/>
+                        <a:latin typeface="Arial"/>
+                      </a:endParaRPr>
+                    </a:p>
+                  </a:txBody>
+                  <a:tcPr anchor="ctr">
+                    <a:lnL w="6480">
+                      <a:solidFill>
+                        <a:srgbClr val="CFCFCF"/>
+                      </a:solidFill>
+                      <a:prstDash val="solid"/>
+                    </a:lnL>
+                    <a:lnR w="6480">
+                      <a:solidFill>
+                        <a:srgbClr val="CFCFCF"/>
+                      </a:solidFill>
+                      <a:prstDash val="solid"/>
+                    </a:lnR>
+                    <a:lnT w="6480">
+                      <a:solidFill>
+                        <a:srgbClr val="CFCFCF"/>
+                      </a:solidFill>
+                      <a:prstDash val="solid"/>
+                    </a:lnT>
+                    <a:lnB w="6480">
+                      <a:solidFill>
+                        <a:srgbClr val="CFCFCF"/>
+                      </a:solidFill>
+                      <a:prstDash val="solid"/>
+                    </a:lnB>
+                    <a:noFill/>
+                  </a:tcPr>
+                </a:tc>
+                <a:extLst>
+                  <a:ext uri="{0D108BD9-81ED-4DB2-BD59-A6C34878D82A}">
+                    <a16:rowId xmlns:a16="http://schemas.microsoft.com/office/drawing/2014/main" val="10002"/>
+                  </a:ext>
+                </a:extLst>
+              </a:tr>
+              <a:tr h="310680">
+                <a:tc>
+                  <a:txBody>
+                    <a:bodyPr/>
+                    <a:lstStyle/>
+                    <a:p>
+                      <a:pPr defTabSz="914400">
+                        <a:lnSpc>
+                          <a:spcPct val="100000"/>
+                        </a:lnSpc>
+                        <a:tabLst>
+                          <a:tab pos="0" algn="l"/>
+                        </a:tabLst>
+                      </a:pPr>
+                      <a:r>
+                        <a:rPr lang="en-US" sz="1200" b="1" u="none" strike="noStrike">
+                          <a:solidFill>
+                            <a:srgbClr val="2C3E50"/>
+                          </a:solidFill>
+                          <a:effectLst/>
+                          <a:uFillTx/>
+                          <a:latin typeface="Calibri"/>
+                          <a:ea typeface="Calibri"/>
+                        </a:rPr>
+                        <a:t>Central IDR</a:t>
+                      </a:r>
+                      <a:endParaRPr lang="en-US" sz="1200" b="0" u="none" strike="noStrike">
+                        <a:solidFill>
+                          <a:srgbClr val="000000"/>
+                        </a:solidFill>
+                        <a:effectLst/>
+                        <a:uFillTx/>
+                        <a:latin typeface="Arial"/>
+                      </a:endParaRPr>
+                    </a:p>
+                  </a:txBody>
+                  <a:tcPr anchor="ctr">
+                    <a:lnL w="6480">
+                      <a:solidFill>
+                        <a:srgbClr val="CFCFCF"/>
+                      </a:solidFill>
+                      <a:prstDash val="solid"/>
+                    </a:lnL>
+                    <a:lnR w="6480">
+                      <a:solidFill>
+                        <a:srgbClr val="CFCFCF"/>
+                      </a:solidFill>
+                      <a:prstDash val="solid"/>
+                    </a:lnR>
+                    <a:lnT w="6480">
+                      <a:solidFill>
+                        <a:srgbClr val="CFCFCF"/>
+                      </a:solidFill>
+                      <a:prstDash val="solid"/>
+                    </a:lnT>
+                    <a:lnB w="6480">
+                      <a:solidFill>
+                        <a:srgbClr val="CFCFCF"/>
+                      </a:solidFill>
+                      <a:prstDash val="solid"/>
+                    </a:lnB>
+                    <a:noFill/>
+                  </a:tcPr>
+                </a:tc>
+                <a:tc>
+                  <a:txBody>
+                    <a:bodyPr/>
+                    <a:lstStyle/>
+                    <a:p>
+                      <a:pPr defTabSz="914400">
+                        <a:lnSpc>
+                          <a:spcPct val="100000"/>
+                        </a:lnSpc>
+                        <a:tabLst>
+                          <a:tab pos="0" algn="l"/>
+                        </a:tabLst>
+                      </a:pPr>
+                      <a:r>
+                        <a:rPr lang="en-US" sz="1200" b="0" u="none" strike="noStrike">
+                          <a:solidFill>
+                            <a:srgbClr val="2C3E50"/>
+                          </a:solidFill>
+                          <a:effectLst/>
+                          <a:uFillTx/>
+                          <a:latin typeface="Calibri"/>
+                          <a:ea typeface="Calibri"/>
+                        </a:rPr>
+                        <a:t>72–142</a:t>
+                      </a:r>
+                      <a:endParaRPr lang="en-US" sz="1200" b="0" u="none" strike="noStrike">
+                        <a:solidFill>
+                          <a:srgbClr val="000000"/>
+                        </a:solidFill>
+                        <a:effectLst/>
+                        <a:uFillTx/>
+                        <a:latin typeface="Arial"/>
+                      </a:endParaRPr>
+                    </a:p>
+                  </a:txBody>
+                  <a:tcPr anchor="ctr">
+                    <a:lnL w="6480">
+                      <a:solidFill>
+                        <a:srgbClr val="CFCFCF"/>
+                      </a:solidFill>
+                      <a:prstDash val="solid"/>
+                    </a:lnL>
+                    <a:lnR w="6480">
+                      <a:solidFill>
+                        <a:srgbClr val="CFCFCF"/>
+                      </a:solidFill>
+                      <a:prstDash val="solid"/>
+                    </a:lnR>
+                    <a:lnT w="6480">
+                      <a:solidFill>
+                        <a:srgbClr val="CFCFCF"/>
+                      </a:solidFill>
+                      <a:prstDash val="solid"/>
+                    </a:lnT>
+                    <a:lnB w="6480">
+                      <a:solidFill>
+                        <a:srgbClr val="CFCFCF"/>
+                      </a:solidFill>
+                      <a:prstDash val="solid"/>
+                    </a:lnB>
+                    <a:noFill/>
+                  </a:tcPr>
+                </a:tc>
+                <a:tc>
+                  <a:txBody>
+                    <a:bodyPr/>
+                    <a:lstStyle/>
+                    <a:p>
+                      <a:pPr defTabSz="914400">
+                        <a:lnSpc>
+                          <a:spcPct val="100000"/>
+                        </a:lnSpc>
+                        <a:tabLst>
+                          <a:tab pos="0" algn="l"/>
+                        </a:tabLst>
+                      </a:pPr>
+                      <a:r>
+                        <a:rPr lang="en-US" sz="1200" b="0" u="none" strike="noStrike" dirty="0">
+                          <a:solidFill>
+                            <a:srgbClr val="2C3E50"/>
+                          </a:solidFill>
+                          <a:effectLst/>
+                          <a:uFillTx/>
+                          <a:latin typeface="Calibri"/>
+                          <a:ea typeface="Calibri"/>
+                        </a:rPr>
+                        <a:t>phospho-cluster</a:t>
+                      </a:r>
+                      <a:endParaRPr lang="en-US" sz="1200" b="0" u="none" strike="noStrike" dirty="0">
+                        <a:solidFill>
+                          <a:srgbClr val="000000"/>
+                        </a:solidFill>
+                        <a:effectLst/>
+                        <a:uFillTx/>
+                        <a:latin typeface="Arial"/>
+                      </a:endParaRPr>
+                    </a:p>
+                  </a:txBody>
+                  <a:tcPr anchor="ctr">
+                    <a:lnL w="6480">
+                      <a:solidFill>
+                        <a:srgbClr val="CFCFCF"/>
+                      </a:solidFill>
+                      <a:prstDash val="solid"/>
+                    </a:lnL>
+                    <a:lnR w="6480">
+                      <a:solidFill>
+                        <a:srgbClr val="CFCFCF"/>
+                      </a:solidFill>
+                      <a:prstDash val="solid"/>
+                    </a:lnR>
+                    <a:lnT w="6480">
+                      <a:solidFill>
+                        <a:srgbClr val="CFCFCF"/>
+                      </a:solidFill>
+                      <a:prstDash val="solid"/>
+                    </a:lnT>
+                    <a:lnB w="6480">
+                      <a:solidFill>
+                        <a:srgbClr val="CFCFCF"/>
+                      </a:solidFill>
+                      <a:prstDash val="solid"/>
+                    </a:lnB>
+                    <a:noFill/>
+                  </a:tcPr>
+                </a:tc>
+                <a:tc>
+                  <a:txBody>
+                    <a:bodyPr/>
+                    <a:lstStyle/>
+                    <a:p>
+                      <a:pPr defTabSz="914400">
+                        <a:lnSpc>
+                          <a:spcPct val="100000"/>
+                        </a:lnSpc>
+                        <a:tabLst>
+                          <a:tab pos="0" algn="l"/>
+                        </a:tabLst>
+                      </a:pPr>
+                      <a:r>
+                        <a:rPr lang="en-US" sz="1200" b="0" u="none" strike="noStrike">
+                          <a:solidFill>
+                            <a:srgbClr val="2C3E50"/>
+                          </a:solidFill>
+                          <a:effectLst/>
+                          <a:uFillTx/>
+                          <a:latin typeface="Calibri"/>
+                          <a:ea typeface="Calibri"/>
+                        </a:rPr>
+                        <a:t>0.70  (90%)</a:t>
+                      </a:r>
+                      <a:endParaRPr lang="en-US" sz="1200" b="0" u="none" strike="noStrike">
+                        <a:solidFill>
+                          <a:srgbClr val="000000"/>
+                        </a:solidFill>
+                        <a:effectLst/>
+                        <a:uFillTx/>
+                        <a:latin typeface="Arial"/>
+                      </a:endParaRPr>
+                    </a:p>
+                  </a:txBody>
+                  <a:tcPr anchor="ctr">
+                    <a:lnL w="6480">
+                      <a:solidFill>
+                        <a:srgbClr val="CFCFCF"/>
+                      </a:solidFill>
+                      <a:prstDash val="solid"/>
+                    </a:lnL>
+                    <a:lnR w="6480">
+                      <a:solidFill>
+                        <a:srgbClr val="CFCFCF"/>
+                      </a:solidFill>
+                      <a:prstDash val="solid"/>
+                    </a:lnR>
+                    <a:lnT w="6480">
+                      <a:solidFill>
+                        <a:srgbClr val="CFCFCF"/>
+                      </a:solidFill>
+                      <a:prstDash val="solid"/>
+                    </a:lnT>
+                    <a:lnB w="6480">
+                      <a:solidFill>
+                        <a:srgbClr val="CFCFCF"/>
+                      </a:solidFill>
+                      <a:prstDash val="solid"/>
+                    </a:lnB>
+                    <a:noFill/>
+                  </a:tcPr>
+                </a:tc>
+                <a:tc>
+                  <a:txBody>
+                    <a:bodyPr/>
+                    <a:lstStyle/>
+                    <a:p>
+                      <a:pPr defTabSz="914400">
+                        <a:lnSpc>
+                          <a:spcPct val="100000"/>
+                        </a:lnSpc>
+                        <a:tabLst>
+                          <a:tab pos="0" algn="l"/>
+                        </a:tabLst>
+                      </a:pPr>
+                      <a:r>
+                        <a:rPr lang="en-US" sz="1200" b="0" i="1" u="none" strike="noStrike">
+                          <a:solidFill>
+                            <a:srgbClr val="2C3E50"/>
+                          </a:solidFill>
+                          <a:effectLst/>
+                          <a:uFillTx/>
+                          <a:latin typeface="Calibri"/>
+                          <a:ea typeface="Calibri"/>
+                        </a:rPr>
+                        <a:t>disordered</a:t>
+                      </a:r>
+                      <a:endParaRPr lang="en-US" sz="1200" b="0" u="none" strike="noStrike">
+                        <a:solidFill>
+                          <a:srgbClr val="000000"/>
+                        </a:solidFill>
+                        <a:effectLst/>
+                        <a:uFillTx/>
+                        <a:latin typeface="Arial"/>
+                      </a:endParaRPr>
+                    </a:p>
+                  </a:txBody>
+                  <a:tcPr anchor="ctr">
+                    <a:lnL w="6480">
+                      <a:solidFill>
+                        <a:srgbClr val="CFCFCF"/>
+                      </a:solidFill>
+                      <a:prstDash val="solid"/>
+                    </a:lnL>
+                    <a:lnR w="6480">
+                      <a:solidFill>
+                        <a:srgbClr val="CFCFCF"/>
+                      </a:solidFill>
+                      <a:prstDash val="solid"/>
+                    </a:lnR>
+                    <a:lnT w="6480">
+                      <a:solidFill>
+                        <a:srgbClr val="CFCFCF"/>
+                      </a:solidFill>
+                      <a:prstDash val="solid"/>
+                    </a:lnT>
+                    <a:lnB w="6480">
+                      <a:solidFill>
+                        <a:srgbClr val="CFCFCF"/>
+                      </a:solidFill>
+                      <a:prstDash val="solid"/>
+                    </a:lnB>
+                    <a:noFill/>
+                  </a:tcPr>
+                </a:tc>
+                <a:extLst>
+                  <a:ext uri="{0D108BD9-81ED-4DB2-BD59-A6C34878D82A}">
+                    <a16:rowId xmlns:a16="http://schemas.microsoft.com/office/drawing/2014/main" val="10003"/>
+                  </a:ext>
+                </a:extLst>
+              </a:tr>
+              <a:tr h="310680">
+                <a:tc>
+                  <a:txBody>
+                    <a:bodyPr/>
+                    <a:lstStyle/>
+                    <a:p>
+                      <a:pPr defTabSz="914400">
+                        <a:lnSpc>
+                          <a:spcPct val="100000"/>
+                        </a:lnSpc>
+                        <a:tabLst>
+                          <a:tab pos="0" algn="l"/>
+                        </a:tabLst>
+                      </a:pPr>
+                      <a:r>
+                        <a:rPr lang="en-US" sz="1200" b="1" u="none" strike="noStrike">
+                          <a:solidFill>
+                            <a:srgbClr val="2C3E50"/>
+                          </a:solidFill>
+                          <a:effectLst/>
+                          <a:uFillTx/>
+                          <a:latin typeface="Calibri"/>
+                          <a:ea typeface="Calibri"/>
+                        </a:rPr>
+                        <a:t>FGF motif</a:t>
+                      </a:r>
+                      <a:endParaRPr lang="en-US" sz="1200" b="0" u="none" strike="noStrike">
+                        <a:solidFill>
+                          <a:srgbClr val="000000"/>
+                        </a:solidFill>
+                        <a:effectLst/>
+                        <a:uFillTx/>
+                        <a:latin typeface="Arial"/>
+                      </a:endParaRPr>
+                    </a:p>
+                  </a:txBody>
+                  <a:tcPr anchor="ctr">
+                    <a:lnL w="6480">
+                      <a:solidFill>
+                        <a:srgbClr val="CFCFCF"/>
+                      </a:solidFill>
+                      <a:prstDash val="solid"/>
+                    </a:lnL>
+                    <a:lnR w="6480">
+                      <a:solidFill>
+                        <a:srgbClr val="CFCFCF"/>
+                      </a:solidFill>
+                      <a:prstDash val="solid"/>
+                    </a:lnR>
+                    <a:lnT w="6480">
+                      <a:solidFill>
+                        <a:srgbClr val="CFCFCF"/>
+                      </a:solidFill>
+                      <a:prstDash val="solid"/>
+                    </a:lnT>
+                    <a:lnB w="6480">
+                      <a:solidFill>
+                        <a:srgbClr val="CFCFCF"/>
+                      </a:solidFill>
+                      <a:prstDash val="solid"/>
+                    </a:lnB>
+                    <a:solidFill>
+                      <a:srgbClr val="F0E8F4"/>
+                    </a:solidFill>
+                  </a:tcPr>
+                </a:tc>
+                <a:tc>
+                  <a:txBody>
+                    <a:bodyPr/>
+                    <a:lstStyle/>
+                    <a:p>
+                      <a:pPr defTabSz="914400">
+                        <a:lnSpc>
+                          <a:spcPct val="100000"/>
+                        </a:lnSpc>
+                        <a:tabLst>
+                          <a:tab pos="0" algn="l"/>
+                        </a:tabLst>
+                      </a:pPr>
+                      <a:r>
+                        <a:rPr lang="en-US" sz="1200" b="0" u="none" strike="noStrike">
+                          <a:solidFill>
+                            <a:srgbClr val="2C3E50"/>
+                          </a:solidFill>
+                          <a:effectLst/>
+                          <a:uFillTx/>
+                          <a:latin typeface="Calibri"/>
+                          <a:ea typeface="Calibri"/>
+                        </a:rPr>
+                        <a:t>166–168</a:t>
+                      </a:r>
+                      <a:endParaRPr lang="en-US" sz="1200" b="0" u="none" strike="noStrike">
+                        <a:solidFill>
+                          <a:srgbClr val="000000"/>
+                        </a:solidFill>
+                        <a:effectLst/>
+                        <a:uFillTx/>
+                        <a:latin typeface="Arial"/>
+                      </a:endParaRPr>
+                    </a:p>
+                  </a:txBody>
+                  <a:tcPr anchor="ctr">
+                    <a:lnL w="6480">
+                      <a:solidFill>
+                        <a:srgbClr val="CFCFCF"/>
+                      </a:solidFill>
+                      <a:prstDash val="solid"/>
+                    </a:lnL>
+                    <a:lnR w="6480">
+                      <a:solidFill>
+                        <a:srgbClr val="CFCFCF"/>
+                      </a:solidFill>
+                      <a:prstDash val="solid"/>
+                    </a:lnR>
+                    <a:lnT w="6480">
+                      <a:solidFill>
+                        <a:srgbClr val="CFCFCF"/>
+                      </a:solidFill>
+                      <a:prstDash val="solid"/>
+                    </a:lnT>
+                    <a:lnB w="6480">
+                      <a:solidFill>
+                        <a:srgbClr val="CFCFCF"/>
+                      </a:solidFill>
+                      <a:prstDash val="solid"/>
+                    </a:lnB>
+                    <a:solidFill>
+                      <a:srgbClr val="F0E8F4"/>
+                    </a:solidFill>
+                  </a:tcPr>
+                </a:tc>
+                <a:tc>
+                  <a:txBody>
+                    <a:bodyPr/>
+                    <a:lstStyle/>
+                    <a:p>
+                      <a:pPr defTabSz="914400">
+                        <a:lnSpc>
+                          <a:spcPct val="100000"/>
+                        </a:lnSpc>
+                        <a:tabLst>
+                          <a:tab pos="0" algn="l"/>
+                        </a:tabLst>
+                      </a:pPr>
+                      <a:r>
+                        <a:rPr lang="en-US" sz="1200" b="0" u="none" strike="noStrike">
+                          <a:solidFill>
+                            <a:srgbClr val="2C3E50"/>
+                          </a:solidFill>
+                          <a:effectLst/>
+                          <a:uFillTx/>
+                          <a:latin typeface="Calibri"/>
+                          <a:ea typeface="Calibri"/>
+                        </a:rPr>
+                        <a:t>PDS5A/B (cohesion)</a:t>
+                      </a:r>
+                      <a:endParaRPr lang="en-US" sz="1200" b="0" u="none" strike="noStrike">
+                        <a:solidFill>
+                          <a:srgbClr val="000000"/>
+                        </a:solidFill>
+                        <a:effectLst/>
+                        <a:uFillTx/>
+                        <a:latin typeface="Arial"/>
+                      </a:endParaRPr>
+                    </a:p>
+                  </a:txBody>
+                  <a:tcPr anchor="ctr">
+                    <a:lnL w="6480">
+                      <a:solidFill>
+                        <a:srgbClr val="CFCFCF"/>
+                      </a:solidFill>
+                      <a:prstDash val="solid"/>
+                    </a:lnL>
+                    <a:lnR w="6480">
+                      <a:solidFill>
+                        <a:srgbClr val="CFCFCF"/>
+                      </a:solidFill>
+                      <a:prstDash val="solid"/>
+                    </a:lnR>
+                    <a:lnT w="6480">
+                      <a:solidFill>
+                        <a:srgbClr val="CFCFCF"/>
+                      </a:solidFill>
+                      <a:prstDash val="solid"/>
+                    </a:lnT>
+                    <a:lnB w="6480">
+                      <a:solidFill>
+                        <a:srgbClr val="CFCFCF"/>
+                      </a:solidFill>
+                      <a:prstDash val="solid"/>
+                    </a:lnB>
+                    <a:solidFill>
+                      <a:srgbClr val="F0E8F4"/>
+                    </a:solidFill>
+                  </a:tcPr>
+                </a:tc>
+                <a:tc>
+                  <a:txBody>
+                    <a:bodyPr/>
+                    <a:lstStyle/>
+                    <a:p>
+                      <a:pPr defTabSz="914400">
+                        <a:lnSpc>
+                          <a:spcPct val="100000"/>
+                        </a:lnSpc>
+                        <a:tabLst>
+                          <a:tab pos="0" algn="l"/>
+                        </a:tabLst>
+                      </a:pPr>
+                      <a:r>
+                        <a:rPr lang="en-US" sz="1200" b="0" u="none" strike="noStrike">
+                          <a:solidFill>
+                            <a:srgbClr val="2C3E50"/>
+                          </a:solidFill>
+                          <a:effectLst/>
+                          <a:uFillTx/>
+                          <a:latin typeface="Calibri"/>
+                          <a:ea typeface="Calibri"/>
+                        </a:rPr>
+                        <a:t>0.47  (33%)</a:t>
+                      </a:r>
+                      <a:endParaRPr lang="en-US" sz="1200" b="0" u="none" strike="noStrike">
+                        <a:solidFill>
+                          <a:srgbClr val="000000"/>
+                        </a:solidFill>
+                        <a:effectLst/>
+                        <a:uFillTx/>
+                        <a:latin typeface="Arial"/>
+                      </a:endParaRPr>
+                    </a:p>
+                  </a:txBody>
+                  <a:tcPr anchor="ctr">
+                    <a:lnL w="6480">
+                      <a:solidFill>
+                        <a:srgbClr val="CFCFCF"/>
+                      </a:solidFill>
+                      <a:prstDash val="solid"/>
+                    </a:lnL>
+                    <a:lnR w="6480">
+                      <a:solidFill>
+                        <a:srgbClr val="CFCFCF"/>
+                      </a:solidFill>
+                      <a:prstDash val="solid"/>
+                    </a:lnR>
+                    <a:lnT w="6480">
+                      <a:solidFill>
+                        <a:srgbClr val="CFCFCF"/>
+                      </a:solidFill>
+                      <a:prstDash val="solid"/>
+                    </a:lnT>
+                    <a:lnB w="6480">
+                      <a:solidFill>
+                        <a:srgbClr val="CFCFCF"/>
+                      </a:solidFill>
+                      <a:prstDash val="solid"/>
+                    </a:lnB>
+                    <a:solidFill>
+                      <a:srgbClr val="F0E8F4"/>
+                    </a:solidFill>
+                  </a:tcPr>
+                </a:tc>
+                <a:tc>
+                  <a:txBody>
+                    <a:bodyPr/>
+                    <a:lstStyle/>
+                    <a:p>
+                      <a:pPr defTabSz="914400">
+                        <a:lnSpc>
+                          <a:spcPct val="100000"/>
+                        </a:lnSpc>
+                        <a:tabLst>
+                          <a:tab pos="0" algn="l"/>
+                        </a:tabLst>
+                      </a:pPr>
+                      <a:r>
+                        <a:rPr lang="en-US" sz="1200" b="0" i="1" u="none" strike="noStrike" dirty="0">
+                          <a:solidFill>
+                            <a:srgbClr val="2C3E50"/>
+                          </a:solidFill>
+                          <a:effectLst/>
+                          <a:uFillTx/>
+                          <a:latin typeface="Calibri"/>
+                          <a:ea typeface="Calibri"/>
+                        </a:rPr>
+                        <a:t>SLiM / ordered dip in IDR</a:t>
+                      </a:r>
+                      <a:endParaRPr lang="en-US" sz="1200" b="0" u="none" strike="noStrike" dirty="0">
+                        <a:solidFill>
+                          <a:srgbClr val="000000"/>
+                        </a:solidFill>
+                        <a:effectLst/>
+                        <a:uFillTx/>
+                        <a:latin typeface="Arial"/>
+                      </a:endParaRPr>
+                    </a:p>
+                  </a:txBody>
+                  <a:tcPr anchor="ctr">
+                    <a:lnL w="6480">
+                      <a:solidFill>
+                        <a:srgbClr val="CFCFCF"/>
+                      </a:solidFill>
+                      <a:prstDash val="solid"/>
+                    </a:lnL>
+                    <a:lnR w="6480">
+                      <a:solidFill>
+                        <a:srgbClr val="CFCFCF"/>
+                      </a:solidFill>
+                      <a:prstDash val="solid"/>
+                    </a:lnR>
+                    <a:lnT w="6480">
+                      <a:solidFill>
+                        <a:srgbClr val="CFCFCF"/>
+                      </a:solidFill>
+                      <a:prstDash val="solid"/>
+                    </a:lnT>
+                    <a:lnB w="6480">
+                      <a:solidFill>
+                        <a:srgbClr val="CFCFCF"/>
+                      </a:solidFill>
+                      <a:prstDash val="solid"/>
+                    </a:lnB>
+                    <a:solidFill>
+                      <a:srgbClr val="F0E8F4"/>
+                    </a:solidFill>
+                  </a:tcPr>
+                </a:tc>
+                <a:extLst>
+                  <a:ext uri="{0D108BD9-81ED-4DB2-BD59-A6C34878D82A}">
+                    <a16:rowId xmlns:a16="http://schemas.microsoft.com/office/drawing/2014/main" val="10004"/>
+                  </a:ext>
+                </a:extLst>
+              </a:tr>
+              <a:tr h="310680">
+                <a:tc>
+                  <a:txBody>
+                    <a:bodyPr/>
+                    <a:lstStyle/>
+                    <a:p>
+                      <a:pPr defTabSz="914400">
+                        <a:lnSpc>
+                          <a:spcPct val="100000"/>
+                        </a:lnSpc>
+                        <a:tabLst>
+                          <a:tab pos="0" algn="l"/>
+                        </a:tabLst>
+                      </a:pPr>
+                      <a:r>
+                        <a:rPr lang="en-US" sz="1200" b="1" u="none" strike="noStrike">
+                          <a:solidFill>
+                            <a:srgbClr val="2C3E50"/>
+                          </a:solidFill>
+                          <a:effectLst/>
+                          <a:uFillTx/>
+                          <a:latin typeface="Calibri"/>
+                          <a:ea typeface="Calibri"/>
+                        </a:rPr>
+                        <a:t>Ser209 site</a:t>
+                      </a:r>
+                      <a:endParaRPr lang="en-US" sz="1200" b="0" u="none" strike="noStrike">
+                        <a:solidFill>
+                          <a:srgbClr val="000000"/>
+                        </a:solidFill>
+                        <a:effectLst/>
+                        <a:uFillTx/>
+                        <a:latin typeface="Arial"/>
+                      </a:endParaRPr>
+                    </a:p>
+                  </a:txBody>
+                  <a:tcPr anchor="ctr">
+                    <a:lnL w="6480">
+                      <a:solidFill>
+                        <a:srgbClr val="CFCFCF"/>
+                      </a:solidFill>
+                      <a:prstDash val="solid"/>
+                    </a:lnL>
+                    <a:lnR w="6480">
+                      <a:solidFill>
+                        <a:srgbClr val="CFCFCF"/>
+                      </a:solidFill>
+                      <a:prstDash val="solid"/>
+                    </a:lnR>
+                    <a:lnT w="6480">
+                      <a:solidFill>
+                        <a:srgbClr val="CFCFCF"/>
+                      </a:solidFill>
+                      <a:prstDash val="solid"/>
+                    </a:lnT>
+                    <a:lnB w="6480">
+                      <a:solidFill>
+                        <a:srgbClr val="CFCFCF"/>
+                      </a:solidFill>
+                      <a:prstDash val="solid"/>
+                    </a:lnB>
+                    <a:noFill/>
+                  </a:tcPr>
+                </a:tc>
+                <a:tc>
+                  <a:txBody>
+                    <a:bodyPr/>
+                    <a:lstStyle/>
+                    <a:p>
+                      <a:pPr defTabSz="914400">
+                        <a:lnSpc>
+                          <a:spcPct val="100000"/>
+                        </a:lnSpc>
+                        <a:tabLst>
+                          <a:tab pos="0" algn="l"/>
+                        </a:tabLst>
+                      </a:pPr>
+                      <a:r>
+                        <a:rPr lang="en-US" sz="1200" b="0" u="none" strike="noStrike">
+                          <a:solidFill>
+                            <a:srgbClr val="2C3E50"/>
+                          </a:solidFill>
+                          <a:effectLst/>
+                          <a:uFillTx/>
+                          <a:latin typeface="Calibri"/>
+                          <a:ea typeface="Calibri"/>
+                        </a:rPr>
+                        <a:t>199–222</a:t>
+                      </a:r>
+                      <a:endParaRPr lang="en-US" sz="1200" b="0" u="none" strike="noStrike">
+                        <a:solidFill>
+                          <a:srgbClr val="000000"/>
+                        </a:solidFill>
+                        <a:effectLst/>
+                        <a:uFillTx/>
+                        <a:latin typeface="Arial"/>
+                      </a:endParaRPr>
+                    </a:p>
+                  </a:txBody>
+                  <a:tcPr anchor="ctr">
+                    <a:lnL w="6480">
+                      <a:solidFill>
+                        <a:srgbClr val="CFCFCF"/>
+                      </a:solidFill>
+                      <a:prstDash val="solid"/>
+                    </a:lnL>
+                    <a:lnR w="6480">
+                      <a:solidFill>
+                        <a:srgbClr val="CFCFCF"/>
+                      </a:solidFill>
+                      <a:prstDash val="solid"/>
+                    </a:lnR>
+                    <a:lnT w="6480">
+                      <a:solidFill>
+                        <a:srgbClr val="CFCFCF"/>
+                      </a:solidFill>
+                      <a:prstDash val="solid"/>
+                    </a:lnT>
+                    <a:lnB w="6480">
+                      <a:solidFill>
+                        <a:srgbClr val="CFCFCF"/>
+                      </a:solidFill>
+                      <a:prstDash val="solid"/>
+                    </a:lnB>
+                    <a:noFill/>
+                  </a:tcPr>
+                </a:tc>
+                <a:tc>
+                  <a:txBody>
+                    <a:bodyPr/>
+                    <a:lstStyle/>
+                    <a:p>
+                      <a:pPr defTabSz="914400">
+                        <a:lnSpc>
+                          <a:spcPct val="100000"/>
+                        </a:lnSpc>
+                        <a:tabLst>
+                          <a:tab pos="0" algn="l"/>
+                        </a:tabLst>
+                      </a:pPr>
+                      <a:r>
+                        <a:rPr lang="en-US" sz="1200" b="0" u="none" strike="noStrike">
+                          <a:solidFill>
+                            <a:srgbClr val="2C3E50"/>
+                          </a:solidFill>
+                          <a:effectLst/>
+                          <a:uFillTx/>
+                          <a:latin typeface="Calibri"/>
+                          <a:ea typeface="Calibri"/>
+                        </a:rPr>
+                        <a:t>ERK2 (phosphorylation)</a:t>
+                      </a:r>
+                      <a:endParaRPr lang="en-US" sz="1200" b="0" u="none" strike="noStrike">
+                        <a:solidFill>
+                          <a:srgbClr val="000000"/>
+                        </a:solidFill>
+                        <a:effectLst/>
+                        <a:uFillTx/>
+                        <a:latin typeface="Arial"/>
+                      </a:endParaRPr>
+                    </a:p>
+                  </a:txBody>
+                  <a:tcPr anchor="ctr">
+                    <a:lnL w="6480">
+                      <a:solidFill>
+                        <a:srgbClr val="CFCFCF"/>
+                      </a:solidFill>
+                      <a:prstDash val="solid"/>
+                    </a:lnL>
+                    <a:lnR w="6480">
+                      <a:solidFill>
+                        <a:srgbClr val="CFCFCF"/>
+                      </a:solidFill>
+                      <a:prstDash val="solid"/>
+                    </a:lnR>
+                    <a:lnT w="6480">
+                      <a:solidFill>
+                        <a:srgbClr val="CFCFCF"/>
+                      </a:solidFill>
+                      <a:prstDash val="solid"/>
+                    </a:lnT>
+                    <a:lnB w="6480">
+                      <a:solidFill>
+                        <a:srgbClr val="CFCFCF"/>
+                      </a:solidFill>
+                      <a:prstDash val="solid"/>
+                    </a:lnB>
+                    <a:noFill/>
+                  </a:tcPr>
+                </a:tc>
+                <a:tc>
+                  <a:txBody>
+                    <a:bodyPr/>
+                    <a:lstStyle/>
+                    <a:p>
+                      <a:pPr defTabSz="914400">
+                        <a:lnSpc>
+                          <a:spcPct val="100000"/>
+                        </a:lnSpc>
+                        <a:tabLst>
+                          <a:tab pos="0" algn="l"/>
+                        </a:tabLst>
+                      </a:pPr>
+                      <a:r>
+                        <a:rPr lang="en-US" sz="1200" b="0" u="none" strike="noStrike">
+                          <a:solidFill>
+                            <a:srgbClr val="2C3E50"/>
+                          </a:solidFill>
+                          <a:effectLst/>
+                          <a:uFillTx/>
+                          <a:latin typeface="Calibri"/>
+                          <a:ea typeface="Calibri"/>
+                        </a:rPr>
+                        <a:t>0.71  (96%)</a:t>
+                      </a:r>
+                      <a:endParaRPr lang="en-US" sz="1200" b="0" u="none" strike="noStrike">
+                        <a:solidFill>
+                          <a:srgbClr val="000000"/>
+                        </a:solidFill>
+                        <a:effectLst/>
+                        <a:uFillTx/>
+                        <a:latin typeface="Arial"/>
+                      </a:endParaRPr>
+                    </a:p>
+                  </a:txBody>
+                  <a:tcPr anchor="ctr">
+                    <a:lnL w="6480">
+                      <a:solidFill>
+                        <a:srgbClr val="CFCFCF"/>
+                      </a:solidFill>
+                      <a:prstDash val="solid"/>
+                    </a:lnL>
+                    <a:lnR w="6480">
+                      <a:solidFill>
+                        <a:srgbClr val="CFCFCF"/>
+                      </a:solidFill>
+                      <a:prstDash val="solid"/>
+                    </a:lnR>
+                    <a:lnT w="6480">
+                      <a:solidFill>
+                        <a:srgbClr val="CFCFCF"/>
+                      </a:solidFill>
+                      <a:prstDash val="solid"/>
+                    </a:lnT>
+                    <a:lnB w="6480">
+                      <a:solidFill>
+                        <a:srgbClr val="CFCFCF"/>
+                      </a:solidFill>
+                      <a:prstDash val="solid"/>
+                    </a:lnB>
+                    <a:noFill/>
+                  </a:tcPr>
+                </a:tc>
+                <a:tc>
+                  <a:txBody>
+                    <a:bodyPr/>
+                    <a:lstStyle/>
+                    <a:p>
+                      <a:pPr defTabSz="914400">
+                        <a:lnSpc>
+                          <a:spcPct val="100000"/>
+                        </a:lnSpc>
+                        <a:tabLst>
+                          <a:tab pos="0" algn="l"/>
+                        </a:tabLst>
+                      </a:pPr>
+                      <a:r>
+                        <a:rPr lang="en-US" sz="1200" b="0" i="1" u="none" strike="noStrike">
+                          <a:solidFill>
+                            <a:srgbClr val="2C3E50"/>
+                          </a:solidFill>
+                          <a:effectLst/>
+                          <a:uFillTx/>
+                          <a:latin typeface="Calibri"/>
+                          <a:ea typeface="Calibri"/>
+                        </a:rPr>
+                        <a:t>disordered</a:t>
+                      </a:r>
+                      <a:endParaRPr lang="en-US" sz="1200" b="0" u="none" strike="noStrike">
+                        <a:solidFill>
+                          <a:srgbClr val="000000"/>
+                        </a:solidFill>
+                        <a:effectLst/>
+                        <a:uFillTx/>
+                        <a:latin typeface="Arial"/>
+                      </a:endParaRPr>
+                    </a:p>
+                  </a:txBody>
+                  <a:tcPr anchor="ctr">
+                    <a:lnL w="6480">
+                      <a:solidFill>
+                        <a:srgbClr val="CFCFCF"/>
+                      </a:solidFill>
+                      <a:prstDash val="solid"/>
+                    </a:lnL>
+                    <a:lnR w="6480">
+                      <a:solidFill>
+                        <a:srgbClr val="CFCFCF"/>
+                      </a:solidFill>
+                      <a:prstDash val="solid"/>
+                    </a:lnR>
+                    <a:lnT w="6480">
+                      <a:solidFill>
+                        <a:srgbClr val="CFCFCF"/>
+                      </a:solidFill>
+                      <a:prstDash val="solid"/>
+                    </a:lnT>
+                    <a:lnB w="6480">
+                      <a:solidFill>
+                        <a:srgbClr val="CFCFCF"/>
+                      </a:solidFill>
+                      <a:prstDash val="solid"/>
+                    </a:lnB>
+                    <a:noFill/>
+                  </a:tcPr>
+                </a:tc>
+                <a:extLst>
+                  <a:ext uri="{0D108BD9-81ED-4DB2-BD59-A6C34878D82A}">
+                    <a16:rowId xmlns:a16="http://schemas.microsoft.com/office/drawing/2014/main" val="10005"/>
+                  </a:ext>
+                </a:extLst>
+              </a:tr>
+              <a:tr h="310680">
+                <a:tc>
+                  <a:txBody>
+                    <a:bodyPr/>
+                    <a:lstStyle/>
+                    <a:p>
+                      <a:pPr defTabSz="914400">
+                        <a:lnSpc>
+                          <a:spcPct val="100000"/>
+                        </a:lnSpc>
+                        <a:tabLst>
+                          <a:tab pos="0" algn="l"/>
+                        </a:tabLst>
+                      </a:pPr>
+                      <a:r>
+                        <a:rPr lang="en-US" sz="1200" b="1" u="none" strike="noStrike">
+                          <a:solidFill>
+                            <a:srgbClr val="2C3E50"/>
+                          </a:solidFill>
+                          <a:effectLst/>
+                          <a:uFillTx/>
+                          <a:latin typeface="Calibri"/>
+                          <a:ea typeface="Calibri"/>
+                        </a:rPr>
+                        <a:t>Sororin domain</a:t>
+                      </a:r>
+                      <a:endParaRPr lang="en-US" sz="1200" b="0" u="none" strike="noStrike">
+                        <a:solidFill>
+                          <a:srgbClr val="000000"/>
+                        </a:solidFill>
+                        <a:effectLst/>
+                        <a:uFillTx/>
+                        <a:latin typeface="Arial"/>
+                      </a:endParaRPr>
+                    </a:p>
+                  </a:txBody>
+                  <a:tcPr anchor="ctr">
+                    <a:lnL w="6480">
+                      <a:solidFill>
+                        <a:srgbClr val="CFCFCF"/>
+                      </a:solidFill>
+                      <a:prstDash val="solid"/>
+                    </a:lnL>
+                    <a:lnR w="6480">
+                      <a:solidFill>
+                        <a:srgbClr val="CFCFCF"/>
+                      </a:solidFill>
+                      <a:prstDash val="solid"/>
+                    </a:lnR>
+                    <a:lnT w="6480">
+                      <a:solidFill>
+                        <a:srgbClr val="CFCFCF"/>
+                      </a:solidFill>
+                      <a:prstDash val="solid"/>
+                    </a:lnT>
+                    <a:lnB w="6480">
+                      <a:solidFill>
+                        <a:srgbClr val="CFCFCF"/>
+                      </a:solidFill>
+                      <a:prstDash val="solid"/>
+                    </a:lnB>
+                    <a:solidFill>
+                      <a:srgbClr val="DCE7F3"/>
+                    </a:solidFill>
+                  </a:tcPr>
+                </a:tc>
+                <a:tc>
+                  <a:txBody>
+                    <a:bodyPr/>
+                    <a:lstStyle/>
+                    <a:p>
+                      <a:pPr defTabSz="914400">
+                        <a:lnSpc>
+                          <a:spcPct val="100000"/>
+                        </a:lnSpc>
+                        <a:tabLst>
+                          <a:tab pos="0" algn="l"/>
+                        </a:tabLst>
+                      </a:pPr>
+                      <a:r>
+                        <a:rPr lang="en-US" sz="1200" b="0" u="none" strike="noStrike">
+                          <a:solidFill>
+                            <a:srgbClr val="2C3E50"/>
+                          </a:solidFill>
+                          <a:effectLst/>
+                          <a:uFillTx/>
+                          <a:latin typeface="Calibri"/>
+                          <a:ea typeface="Calibri"/>
+                        </a:rPr>
+                        <a:t>230–252</a:t>
+                      </a:r>
+                      <a:endParaRPr lang="en-US" sz="1200" b="0" u="none" strike="noStrike">
+                        <a:solidFill>
+                          <a:srgbClr val="000000"/>
+                        </a:solidFill>
+                        <a:effectLst/>
+                        <a:uFillTx/>
+                        <a:latin typeface="Arial"/>
+                      </a:endParaRPr>
+                    </a:p>
+                  </a:txBody>
+                  <a:tcPr anchor="ctr">
+                    <a:lnL w="6480">
+                      <a:solidFill>
+                        <a:srgbClr val="CFCFCF"/>
+                      </a:solidFill>
+                      <a:prstDash val="solid"/>
+                    </a:lnL>
+                    <a:lnR w="6480">
+                      <a:solidFill>
+                        <a:srgbClr val="CFCFCF"/>
+                      </a:solidFill>
+                      <a:prstDash val="solid"/>
+                    </a:lnR>
+                    <a:lnT w="6480">
+                      <a:solidFill>
+                        <a:srgbClr val="CFCFCF"/>
+                      </a:solidFill>
+                      <a:prstDash val="solid"/>
+                    </a:lnT>
+                    <a:lnB w="6480">
+                      <a:solidFill>
+                        <a:srgbClr val="CFCFCF"/>
+                      </a:solidFill>
+                      <a:prstDash val="solid"/>
+                    </a:lnB>
+                    <a:solidFill>
+                      <a:srgbClr val="DCE7F3"/>
+                    </a:solidFill>
+                  </a:tcPr>
+                </a:tc>
+                <a:tc>
+                  <a:txBody>
+                    <a:bodyPr/>
+                    <a:lstStyle/>
+                    <a:p>
+                      <a:pPr defTabSz="914400">
+                        <a:lnSpc>
+                          <a:spcPct val="100000"/>
+                        </a:lnSpc>
+                        <a:tabLst>
+                          <a:tab pos="0" algn="l"/>
+                        </a:tabLst>
+                      </a:pPr>
+                      <a:r>
+                        <a:rPr lang="en-US" sz="1200" b="0" u="none" strike="noStrike">
+                          <a:solidFill>
+                            <a:srgbClr val="2C3E50"/>
+                          </a:solidFill>
+                          <a:effectLst/>
+                          <a:uFillTx/>
+                          <a:latin typeface="Calibri"/>
+                          <a:ea typeface="Calibri"/>
+                        </a:rPr>
+                        <a:t>cohesin core association</a:t>
+                      </a:r>
+                      <a:endParaRPr lang="en-US" sz="1200" b="0" u="none" strike="noStrike">
+                        <a:solidFill>
+                          <a:srgbClr val="000000"/>
+                        </a:solidFill>
+                        <a:effectLst/>
+                        <a:uFillTx/>
+                        <a:latin typeface="Arial"/>
+                      </a:endParaRPr>
+                    </a:p>
+                  </a:txBody>
+                  <a:tcPr anchor="ctr">
+                    <a:lnL w="6480">
+                      <a:solidFill>
+                        <a:srgbClr val="CFCFCF"/>
+                      </a:solidFill>
+                      <a:prstDash val="solid"/>
+                    </a:lnL>
+                    <a:lnR w="6480">
+                      <a:solidFill>
+                        <a:srgbClr val="CFCFCF"/>
+                      </a:solidFill>
+                      <a:prstDash val="solid"/>
+                    </a:lnR>
+                    <a:lnT w="6480">
+                      <a:solidFill>
+                        <a:srgbClr val="CFCFCF"/>
+                      </a:solidFill>
+                      <a:prstDash val="solid"/>
+                    </a:lnT>
+                    <a:lnB w="6480">
+                      <a:solidFill>
+                        <a:srgbClr val="CFCFCF"/>
+                      </a:solidFill>
+                      <a:prstDash val="solid"/>
+                    </a:lnB>
+                    <a:solidFill>
+                      <a:srgbClr val="DCE7F3"/>
+                    </a:solidFill>
+                  </a:tcPr>
+                </a:tc>
+                <a:tc>
+                  <a:txBody>
+                    <a:bodyPr/>
+                    <a:lstStyle/>
+                    <a:p>
+                      <a:pPr defTabSz="914400">
+                        <a:lnSpc>
+                          <a:spcPct val="100000"/>
+                        </a:lnSpc>
+                        <a:tabLst>
+                          <a:tab pos="0" algn="l"/>
+                        </a:tabLst>
+                      </a:pPr>
+                      <a:r>
+                        <a:rPr lang="en-US" sz="1200" b="0" u="none" strike="noStrike">
+                          <a:solidFill>
+                            <a:srgbClr val="2C3E50"/>
+                          </a:solidFill>
+                          <a:effectLst/>
+                          <a:uFillTx/>
+                          <a:latin typeface="Calibri"/>
+                          <a:ea typeface="Calibri"/>
+                        </a:rPr>
+                        <a:t>0.31  (0%)</a:t>
+                      </a:r>
+                      <a:endParaRPr lang="en-US" sz="1200" b="0" u="none" strike="noStrike">
+                        <a:solidFill>
+                          <a:srgbClr val="000000"/>
+                        </a:solidFill>
+                        <a:effectLst/>
+                        <a:uFillTx/>
+                        <a:latin typeface="Arial"/>
+                      </a:endParaRPr>
+                    </a:p>
+                  </a:txBody>
+                  <a:tcPr anchor="ctr">
+                    <a:lnL w="6480">
+                      <a:solidFill>
+                        <a:srgbClr val="CFCFCF"/>
+                      </a:solidFill>
+                      <a:prstDash val="solid"/>
+                    </a:lnL>
+                    <a:lnR w="6480">
+                      <a:solidFill>
+                        <a:srgbClr val="CFCFCF"/>
+                      </a:solidFill>
+                      <a:prstDash val="solid"/>
+                    </a:lnR>
+                    <a:lnT w="6480">
+                      <a:solidFill>
+                        <a:srgbClr val="CFCFCF"/>
+                      </a:solidFill>
+                      <a:prstDash val="solid"/>
+                    </a:lnT>
+                    <a:lnB w="6480">
+                      <a:solidFill>
+                        <a:srgbClr val="CFCFCF"/>
+                      </a:solidFill>
+                      <a:prstDash val="solid"/>
+                    </a:lnB>
+                    <a:solidFill>
+                      <a:srgbClr val="DCE7F3"/>
+                    </a:solidFill>
+                  </a:tcPr>
+                </a:tc>
+                <a:tc>
+                  <a:txBody>
+                    <a:bodyPr/>
+                    <a:lstStyle/>
+                    <a:p>
+                      <a:pPr defTabSz="914400">
+                        <a:lnSpc>
+                          <a:spcPct val="100000"/>
+                        </a:lnSpc>
+                        <a:tabLst>
+                          <a:tab pos="0" algn="l"/>
+                        </a:tabLst>
+                      </a:pPr>
+                      <a:r>
+                        <a:rPr lang="en-US" sz="1200" b="0" i="1" u="none" strike="noStrike" dirty="0">
+                          <a:solidFill>
+                            <a:srgbClr val="2C3E50"/>
+                          </a:solidFill>
+                          <a:effectLst/>
+                          <a:uFillTx/>
+                          <a:latin typeface="Calibri"/>
+                          <a:ea typeface="Calibri"/>
+                        </a:rPr>
+                        <a:t>folded</a:t>
+                      </a:r>
+                      <a:endParaRPr lang="en-US" sz="1200" b="0" u="none" strike="noStrike" dirty="0">
+                        <a:solidFill>
+                          <a:srgbClr val="000000"/>
+                        </a:solidFill>
+                        <a:effectLst/>
+                        <a:uFillTx/>
+                        <a:latin typeface="Arial"/>
+                      </a:endParaRPr>
+                    </a:p>
+                  </a:txBody>
+                  <a:tcPr anchor="ctr">
+                    <a:lnL w="6480">
+                      <a:solidFill>
+                        <a:srgbClr val="CFCFCF"/>
+                      </a:solidFill>
+                      <a:prstDash val="solid"/>
+                    </a:lnL>
+                    <a:lnR w="6480">
+                      <a:solidFill>
+                        <a:srgbClr val="CFCFCF"/>
+                      </a:solidFill>
+                      <a:prstDash val="solid"/>
+                    </a:lnR>
+                    <a:lnT w="6480">
+                      <a:solidFill>
+                        <a:srgbClr val="CFCFCF"/>
+                      </a:solidFill>
+                      <a:prstDash val="solid"/>
+                    </a:lnT>
+                    <a:lnB w="6480">
+                      <a:solidFill>
+                        <a:srgbClr val="CFCFCF"/>
+                      </a:solidFill>
+                      <a:prstDash val="solid"/>
+                    </a:lnB>
+                    <a:solidFill>
+                      <a:srgbClr val="DCE7F3"/>
+                    </a:solidFill>
+                  </a:tcPr>
+                </a:tc>
+                <a:extLst>
+                  <a:ext uri="{0D108BD9-81ED-4DB2-BD59-A6C34878D82A}">
+                    <a16:rowId xmlns:a16="http://schemas.microsoft.com/office/drawing/2014/main" val="10006"/>
+                  </a:ext>
+                </a:extLst>
+              </a:tr>
+            </a:tbl>
+          </a:graphicData>
+        </a:graphic>
+      </p:graphicFrame>
+      <p:sp>
+        <p:nvSpPr>
+          <p:cNvPr id="11" name="Text 2"/>
+          <p:cNvSpPr/>
+          <p:nvPr/>
+        </p:nvSpPr>
+        <p:spPr>
+          <a:xfrm>
+            <a:off x="502200" y="3337893"/>
+            <a:ext cx="11155320" cy="707431"/>
+          </a:xfrm>
+          <a:prstGeom prst="rect">
+            <a:avLst/>
+          </a:prstGeom>
+          <a:noFill/>
+          <a:ln w="0">
+            <a:noFill/>
+          </a:ln>
+        </p:spPr>
+        <p:style>
+          <a:lnRef idx="0">
+            <a:scrgbClr r="0" g="0" b="0"/>
+          </a:lnRef>
+          <a:fillRef idx="0">
+            <a:scrgbClr r="0" g="0" b="0"/>
+          </a:fillRef>
+          <a:effectRef idx="0">
+            <a:scrgbClr r="0" g="0" b="0"/>
+          </a:effectRef>
+          <a:fontRef idx="minor"/>
+        </p:style>
+        <p:txBody>
+          <a:bodyPr lIns="90000" tIns="45000" rIns="90000" bIns="45000" anchor="t">
+            <a:noAutofit/>
+          </a:bodyPr>
+          <a:lstStyle/>
+          <a:p>
+            <a:pPr defTabSz="914400">
+              <a:lnSpc>
+                <a:spcPct val="100000"/>
+              </a:lnSpc>
+              <a:tabLst>
+                <a:tab pos="0" algn="l"/>
+              </a:tabLst>
+            </a:pPr>
+            <a:r>
+              <a:rPr lang="en-US" sz="1250" b="0" u="none" strike="noStrike" dirty="0">
+                <a:solidFill>
+                  <a:srgbClr val="2C3E50"/>
+                </a:solidFill>
+                <a:effectLst/>
+                <a:uFillTx/>
+                <a:latin typeface="Calibri"/>
+                <a:ea typeface="Calibri"/>
+              </a:rPr>
+              <a:t>Only the C-terminal Sororin domain is folded (0.31, 0% disordered) — the </a:t>
+            </a:r>
+            <a:r>
+              <a:rPr lang="en-US" sz="1250" dirty="0">
+                <a:solidFill>
+                  <a:srgbClr val="2C3E50"/>
+                </a:solidFill>
+                <a:latin typeface="Calibri"/>
+                <a:ea typeface="Calibri"/>
+              </a:rPr>
+              <a:t>C</a:t>
+            </a:r>
+            <a:r>
+              <a:rPr lang="en-US" sz="1250" b="0" u="none" strike="noStrike" dirty="0">
+                <a:solidFill>
+                  <a:srgbClr val="2C3E50"/>
+                </a:solidFill>
+                <a:effectLst/>
+                <a:uFillTx/>
+                <a:latin typeface="Calibri"/>
+                <a:ea typeface="Calibri"/>
+              </a:rPr>
+              <a:t>ohesin anchor. Every other determinant sits in disorder.  </a:t>
+            </a:r>
+            <a:endParaRPr lang="en-US" sz="1250" b="0" u="none" strike="noStrike" dirty="0">
+              <a:solidFill>
+                <a:srgbClr val="000000"/>
+              </a:solidFill>
+              <a:effectLst/>
+              <a:uFillTx/>
+              <a:latin typeface="Arial"/>
+            </a:endParaRPr>
+          </a:p>
+          <a:p>
+            <a:pPr defTabSz="914400">
+              <a:lnSpc>
+                <a:spcPct val="100000"/>
+              </a:lnSpc>
+              <a:tabLst>
+                <a:tab pos="0" algn="l"/>
+              </a:tabLst>
+            </a:pPr>
+            <a:r>
+              <a:rPr lang="en-US" sz="1250" b="0" u="none" strike="noStrike" dirty="0">
+                <a:solidFill>
+                  <a:srgbClr val="2C3E50"/>
+                </a:solidFill>
+                <a:effectLst/>
+                <a:uFillTx/>
+                <a:latin typeface="Calibri"/>
+                <a:ea typeface="Calibri"/>
+              </a:rPr>
+              <a:t>The apparent exception — the FGF motif (0.47) — is a short-ordered</a:t>
+            </a:r>
+            <a:r>
+              <a:rPr lang="en-US" sz="1250" b="1" u="none" strike="noStrike" dirty="0">
+                <a:solidFill>
+                  <a:srgbClr val="762A83"/>
+                </a:solidFill>
+                <a:effectLst/>
+                <a:uFillTx/>
+                <a:latin typeface="Calibri"/>
+                <a:ea typeface="Calibri"/>
+              </a:rPr>
+              <a:t> dip inside disorder</a:t>
+            </a:r>
+            <a:r>
+              <a:rPr lang="en-US" sz="1250" b="0" u="none" strike="noStrike" dirty="0">
+                <a:solidFill>
+                  <a:srgbClr val="2C3E50"/>
+                </a:solidFill>
+                <a:effectLst/>
+                <a:uFillTx/>
+                <a:latin typeface="Calibri"/>
+                <a:ea typeface="Calibri"/>
+              </a:rPr>
+              <a:t>: the classic </a:t>
+            </a:r>
+            <a:r>
+              <a:rPr lang="en-US" sz="1250" b="0" u="none" strike="noStrike" dirty="0">
+                <a:solidFill>
+                  <a:srgbClr val="00B050"/>
+                </a:solidFill>
+                <a:effectLst/>
+                <a:uFillTx/>
+                <a:latin typeface="Calibri"/>
+                <a:ea typeface="Calibri"/>
+              </a:rPr>
+              <a:t>S</a:t>
+            </a:r>
+            <a:r>
+              <a:rPr lang="en-US" sz="1250" b="0" u="none" strike="noStrike" dirty="0">
+                <a:solidFill>
+                  <a:srgbClr val="2C3E50"/>
+                </a:solidFill>
+                <a:effectLst/>
+                <a:uFillTx/>
+                <a:latin typeface="Calibri"/>
+                <a:ea typeface="Calibri"/>
+              </a:rPr>
+              <a:t>hort-</a:t>
+            </a:r>
+            <a:r>
+              <a:rPr lang="en-US" sz="1250" b="0" u="none" strike="noStrike" dirty="0">
+                <a:solidFill>
+                  <a:srgbClr val="00B050"/>
+                </a:solidFill>
+                <a:effectLst/>
+                <a:uFillTx/>
+                <a:latin typeface="Calibri"/>
+                <a:ea typeface="Calibri"/>
+              </a:rPr>
+              <a:t>Li</a:t>
+            </a:r>
+            <a:r>
+              <a:rPr lang="en-US" sz="1250" b="0" u="none" strike="noStrike" dirty="0">
+                <a:solidFill>
+                  <a:srgbClr val="2C3E50"/>
+                </a:solidFill>
+                <a:effectLst/>
+                <a:uFillTx/>
+                <a:latin typeface="Calibri"/>
+                <a:ea typeface="Calibri"/>
+              </a:rPr>
+              <a:t>near-</a:t>
+            </a:r>
+            <a:r>
+              <a:rPr lang="en-US" sz="1250" b="0" u="none" strike="noStrike" dirty="0">
+                <a:solidFill>
+                  <a:srgbClr val="00B050"/>
+                </a:solidFill>
+                <a:effectLst/>
+                <a:uFillTx/>
+                <a:latin typeface="Calibri"/>
+                <a:ea typeface="Calibri"/>
+              </a:rPr>
+              <a:t>M</a:t>
+            </a:r>
+            <a:r>
+              <a:rPr lang="en-US" sz="1250" b="0" u="none" strike="noStrike" dirty="0">
+                <a:solidFill>
+                  <a:srgbClr val="2C3E50"/>
+                </a:solidFill>
+                <a:effectLst/>
+                <a:uFillTx/>
+                <a:latin typeface="Calibri"/>
+                <a:ea typeface="Calibri"/>
+              </a:rPr>
+              <a:t>otif (</a:t>
+            </a:r>
+            <a:r>
+              <a:rPr lang="en-US" sz="1250" b="0" u="none" strike="noStrike" dirty="0">
+                <a:solidFill>
+                  <a:srgbClr val="00B050"/>
+                </a:solidFill>
+                <a:effectLst/>
+                <a:uFillTx/>
+                <a:latin typeface="Calibri"/>
+                <a:ea typeface="Calibri"/>
+              </a:rPr>
+              <a:t>SLiM</a:t>
+            </a:r>
+            <a:r>
+              <a:rPr lang="en-US" sz="1250" b="0" u="none" strike="noStrike" dirty="0">
+                <a:solidFill>
+                  <a:srgbClr val="2C3E50"/>
+                </a:solidFill>
+                <a:effectLst/>
+                <a:uFillTx/>
+                <a:latin typeface="Calibri"/>
+                <a:ea typeface="Calibri"/>
+              </a:rPr>
+              <a:t>) signature — it becomes structured locally only to grab PDS5, which </a:t>
+            </a:r>
+            <a:r>
+              <a:rPr lang="en-US" sz="1250" b="1" i="1" u="none" strike="noStrike" dirty="0">
+                <a:solidFill>
+                  <a:srgbClr val="2C3E50"/>
+                </a:solidFill>
+                <a:effectLst/>
+                <a:uFillTx/>
+                <a:latin typeface="Calibri"/>
+                <a:ea typeface="Calibri"/>
+              </a:rPr>
+              <a:t>supports</a:t>
+            </a:r>
+            <a:r>
+              <a:rPr lang="en-US" sz="1250" b="0" u="none" strike="noStrike" dirty="0">
+                <a:solidFill>
+                  <a:srgbClr val="2C3E50"/>
+                </a:solidFill>
+                <a:effectLst/>
+                <a:uFillTx/>
+                <a:latin typeface="Calibri"/>
+                <a:ea typeface="Calibri"/>
+              </a:rPr>
+              <a:t> the fuzzy-hub picture rather than contradicting it.</a:t>
+            </a:r>
+            <a:endParaRPr lang="en-US" sz="1250" b="0" u="none" strike="noStrike" dirty="0">
+              <a:solidFill>
+                <a:srgbClr val="000000"/>
+              </a:solidFill>
+              <a:effectLst/>
+              <a:uFillTx/>
+              <a:latin typeface="Arial"/>
+            </a:endParaRPr>
+          </a:p>
+        </p:txBody>
+      </p:sp>
+      <p:sp>
+        <p:nvSpPr>
+          <p:cNvPr id="12" name="Text 3"/>
+          <p:cNvSpPr/>
+          <p:nvPr/>
+        </p:nvSpPr>
+        <p:spPr>
+          <a:xfrm>
+            <a:off x="516752" y="4216825"/>
+            <a:ext cx="11155320" cy="548280"/>
+          </a:xfrm>
+          <a:prstGeom prst="roundRect">
+            <a:avLst>
+              <a:gd name="adj" fmla="val 8333"/>
+            </a:avLst>
+          </a:prstGeom>
+          <a:solidFill>
+            <a:srgbClr val="F7F7F7"/>
+          </a:solidFill>
+          <a:ln w="9525">
+            <a:solidFill>
+              <a:srgbClr val="5A6B7B"/>
+            </a:solidFill>
+            <a:round/>
+          </a:ln>
+        </p:spPr>
+        <p:style>
+          <a:lnRef idx="0">
+            <a:scrgbClr r="0" g="0" b="0"/>
+          </a:lnRef>
+          <a:fillRef idx="0">
+            <a:scrgbClr r="0" g="0" b="0"/>
+          </a:fillRef>
+          <a:effectRef idx="0">
+            <a:scrgbClr r="0" g="0" b="0"/>
+          </a:effectRef>
+          <a:fontRef idx="minor"/>
+        </p:style>
+        <p:txBody>
+          <a:bodyPr lIns="63360" tIns="63360" rIns="63360" bIns="63360" anchor="ctr">
+            <a:noAutofit/>
+          </a:bodyPr>
+          <a:lstStyle/>
+          <a:p>
+            <a:pPr algn="ctr">
+              <a:tabLst>
+                <a:tab pos="0" algn="l"/>
+              </a:tabLst>
+            </a:pPr>
+            <a:r>
+              <a:rPr lang="en-US" sz="1400" b="0" u="none" strike="noStrike" dirty="0">
+                <a:solidFill>
+                  <a:srgbClr val="2C3E50"/>
+                </a:solidFill>
+                <a:effectLst/>
+                <a:uFillTx/>
+                <a:latin typeface="Calibri"/>
+              </a:rPr>
+              <a:t>→  </a:t>
+            </a:r>
+            <a:r>
+              <a:rPr lang="en-US" sz="1400" dirty="0"/>
+              <a:t>Sororin engages multiple partners through short linear motifs (SLiMs) embedded within intrinsically disordered regions </a:t>
+            </a:r>
+            <a:r>
+              <a:rPr lang="en-US" sz="1400" b="0" u="none" strike="noStrike" dirty="0">
+                <a:solidFill>
+                  <a:srgbClr val="2C3E50"/>
+                </a:solidFill>
+                <a:effectLst/>
+                <a:uFillTx/>
+                <a:latin typeface="Calibri"/>
+              </a:rPr>
+              <a:t>=  </a:t>
+            </a:r>
+            <a:r>
+              <a:rPr lang="en-US" sz="1400" b="1" u="none" strike="noStrike" dirty="0">
+                <a:solidFill>
+                  <a:srgbClr val="B9770E"/>
+                </a:solidFill>
+                <a:effectLst/>
+                <a:uFillTx/>
+                <a:latin typeface="Calibri"/>
+              </a:rPr>
+              <a:t>a fuzzy interaction hub.</a:t>
+            </a:r>
+            <a:endParaRPr lang="en-US" sz="1400" b="0" u="none" strike="noStrike" dirty="0">
+              <a:solidFill>
+                <a:srgbClr val="000000"/>
+              </a:solidFill>
+              <a:effectLst/>
+              <a:uFillTx/>
+              <a:latin typeface="Arial"/>
+            </a:endParaRPr>
+          </a:p>
+        </p:txBody>
+      </p:sp>
+    </p:spTree>
+  </p:cSld>
+  <p:clrMapOvr>
+    <a:masterClrMapping/>
+  </p:clrMapOvr>
+  <p:timing>
+    <p:tnLst>
+      <p:par>
+        <p:cTn id="1" dur="indefinite" restart="never" nodeType="tmRoot">
+          <p:childTnLst>
+            <p:seq concurrent="1" nextAc="seek">
+              <p:cTn id="2" dur="indefinite" nodeType="mainSeq">
+                <p:childTnLst>
+                  <p:par>
+                    <p:cTn id="3" fill="hold">
+                      <p:stCondLst>
+                        <p:cond delay="indefinite"/>
+                      </p:stCondLst>
+                      <p:childTnLst>
+                        <p:par>
+                          <p:cTn id="4" fill="hold">
+                            <p:stCondLst>
+                              <p:cond delay="0"/>
+                            </p:stCondLst>
+                            <p:childTnLst>
+                              <p:par>
+                                <p:cTn id="5" presetID="22" presetClass="entr" presetSubtype="1" fill="hold" nodeType="clickEffect">
+                                  <p:stCondLst>
+                                    <p:cond delay="0"/>
+                                  </p:stCondLst>
+                                  <p:childTnLst>
+                                    <p:set>
+                                      <p:cBhvr>
+                                        <p:cTn id="6" dur="1" fill="hold">
+                                          <p:stCondLst>
+                                            <p:cond delay="0"/>
+                                          </p:stCondLst>
+                                        </p:cTn>
+                                        <p:tgtEl>
+                                          <p:spTgt spid="10"/>
+                                        </p:tgtEl>
+                                        <p:attrNameLst>
+                                          <p:attrName>style.visibility</p:attrName>
+                                        </p:attrNameLst>
+                                      </p:cBhvr>
+                                      <p:to>
+                                        <p:strVal val="visible"/>
+                                      </p:to>
+                                    </p:set>
+                                    <p:animEffect transition="in" filter="wipe(up)">
+                                      <p:cBhvr>
+                                        <p:cTn id="7" dur="500"/>
+                                        <p:tgtEl>
+                                          <p:spTgt spid="10"/>
+                                        </p:tgtEl>
+                                      </p:cBhvr>
+                                    </p:animEffect>
+                                  </p:childTnLst>
+                                </p:cTn>
+                              </p:par>
+                            </p:childTnLst>
+                          </p:cTn>
+                        </p:par>
+                      </p:childTnLst>
+                    </p:cTn>
+                  </p:par>
+                  <p:par>
+                    <p:cTn id="8" fill="hold">
+                      <p:stCondLst>
+                        <p:cond delay="indefinite"/>
+                      </p:stCondLst>
+                      <p:childTnLst>
+                        <p:par>
+                          <p:cTn id="9" fill="hold">
+                            <p:stCondLst>
+                              <p:cond delay="0"/>
+                            </p:stCondLst>
+                            <p:childTnLst>
+                              <p:par>
+                                <p:cTn id="10" presetID="42" presetClass="entr" presetSubtype="0" fill="hold" grpId="0" nodeType="clickEffect">
+                                  <p:stCondLst>
+                                    <p:cond delay="0"/>
+                                  </p:stCondLst>
+                                  <p:childTnLst>
+                                    <p:set>
+                                      <p:cBhvr>
+                                        <p:cTn id="11" dur="1" fill="hold">
+                                          <p:stCondLst>
+                                            <p:cond delay="0"/>
+                                          </p:stCondLst>
+                                        </p:cTn>
+                                        <p:tgtEl>
+                                          <p:spTgt spid="11"/>
+                                        </p:tgtEl>
+                                        <p:attrNameLst>
+                                          <p:attrName>style.visibility</p:attrName>
+                                        </p:attrNameLst>
+                                      </p:cBhvr>
+                                      <p:to>
+                                        <p:strVal val="visible"/>
+                                      </p:to>
+                                    </p:set>
+                                    <p:animEffect transition="in" filter="fade">
+                                      <p:cBhvr>
+                                        <p:cTn id="12" dur="1000"/>
+                                        <p:tgtEl>
+                                          <p:spTgt spid="11"/>
+                                        </p:tgtEl>
+                                      </p:cBhvr>
+                                    </p:animEffect>
+                                    <p:anim calcmode="lin" valueType="num">
+                                      <p:cBhvr>
+                                        <p:cTn id="13" dur="1000" fill="hold"/>
+                                        <p:tgtEl>
+                                          <p:spTgt spid="11"/>
+                                        </p:tgtEl>
+                                        <p:attrNameLst>
+                                          <p:attrName>ppt_x</p:attrName>
+                                        </p:attrNameLst>
+                                      </p:cBhvr>
+                                      <p:tavLst>
+                                        <p:tav tm="0">
+                                          <p:val>
+                                            <p:strVal val="#ppt_x"/>
+                                          </p:val>
+                                        </p:tav>
+                                        <p:tav tm="100000">
+                                          <p:val>
+                                            <p:strVal val="#ppt_x"/>
+                                          </p:val>
+                                        </p:tav>
+                                      </p:tavLst>
+                                    </p:anim>
+                                    <p:anim calcmode="lin" valueType="num">
+                                      <p:cBhvr>
+                                        <p:cTn id="14" dur="1000" fill="hold"/>
+                                        <p:tgtEl>
+                                          <p:spTgt spid="11"/>
+                                        </p:tgtEl>
+                                        <p:attrNameLst>
+                                          <p:attrName>ppt_y</p:attrName>
+                                        </p:attrNameLst>
+                                      </p:cBhvr>
+                                      <p:tavLst>
+                                        <p:tav tm="0">
+                                          <p:val>
+                                            <p:strVal val="#ppt_y+.1"/>
+                                          </p:val>
+                                        </p:tav>
+                                        <p:tav tm="100000">
+                                          <p:val>
+                                            <p:strVal val="#ppt_y"/>
+                                          </p:val>
+                                        </p:tav>
+                                      </p:tavLst>
+                                    </p:anim>
+                                  </p:childTnLst>
+                                </p:cTn>
+                              </p:par>
+                            </p:childTnLst>
+                          </p:cTn>
+                        </p:par>
+                      </p:childTnLst>
+                    </p:cTn>
+                  </p:par>
+                  <p:par>
+                    <p:cTn id="15" fill="hold">
+                      <p:stCondLst>
+                        <p:cond delay="indefinite"/>
+                      </p:stCondLst>
+                      <p:childTnLst>
+                        <p:par>
+                          <p:cTn id="16" fill="hold">
+                            <p:stCondLst>
+                              <p:cond delay="0"/>
+                            </p:stCondLst>
+                            <p:childTnLst>
+                              <p:par>
+                                <p:cTn id="17" presetID="10" presetClass="entr" presetSubtype="0" fill="hold" grpId="0" nodeType="clickEffect">
+                                  <p:stCondLst>
+                                    <p:cond delay="0"/>
+                                  </p:stCondLst>
+                                  <p:childTnLst>
+                                    <p:set>
+                                      <p:cBhvr>
+                                        <p:cTn id="18" dur="1" fill="hold">
+                                          <p:stCondLst>
+                                            <p:cond delay="0"/>
+                                          </p:stCondLst>
+                                        </p:cTn>
+                                        <p:tgtEl>
+                                          <p:spTgt spid="12"/>
+                                        </p:tgtEl>
+                                        <p:attrNameLst>
+                                          <p:attrName>style.visibility</p:attrName>
+                                        </p:attrNameLst>
+                                      </p:cBhvr>
+                                      <p:to>
+                                        <p:strVal val="visible"/>
+                                      </p:to>
+                                    </p:set>
+                                    <p:animEffect transition="in" filter="fade">
+                                      <p:cBhvr>
+                                        <p:cTn id="19" dur="500"/>
+                                        <p:tgtEl>
+                                          <p:spTgt spid="12"/>
+                                        </p:tgtEl>
+                                      </p:cBhvr>
+                                    </p:animEffect>
+                                  </p:childTnLst>
+                                </p:cTn>
+                              </p:par>
+                            </p:childTnLst>
+                          </p:cTn>
+                        </p:par>
+                      </p:childTnLst>
+                    </p:cTn>
+                  </p:par>
+                  <p:par>
+                    <p:cTn id="20" fill="hold">
+                      <p:stCondLst>
+                        <p:cond delay="indefinite"/>
+                      </p:stCondLst>
+                      <p:childTnLst>
+                        <p:par>
+                          <p:cTn id="21" fill="hold">
+                            <p:stCondLst>
+                              <p:cond delay="0"/>
+                            </p:stCondLst>
+                            <p:childTnLst>
+                              <p:par>
+                                <p:cTn id="22" presetID="55" presetClass="entr" presetSubtype="0" fill="hold" grpId="0" nodeType="clickEffect">
+                                  <p:stCondLst>
+                                    <p:cond delay="0"/>
+                                  </p:stCondLst>
+                                  <p:childTnLst>
+                                    <p:set>
+                                      <p:cBhvr>
+                                        <p:cTn id="23" dur="1" fill="hold">
+                                          <p:stCondLst>
+                                            <p:cond delay="0"/>
+                                          </p:stCondLst>
+                                        </p:cTn>
+                                        <p:tgtEl>
+                                          <p:spTgt spid="9"/>
+                                        </p:tgtEl>
+                                        <p:attrNameLst>
+                                          <p:attrName>style.visibility</p:attrName>
+                                        </p:attrNameLst>
+                                      </p:cBhvr>
+                                      <p:to>
+                                        <p:strVal val="visible"/>
+                                      </p:to>
+                                    </p:set>
+                                    <p:anim calcmode="lin" valueType="num">
+                                      <p:cBhvr>
+                                        <p:cTn id="24" dur="1000" fill="hold"/>
+                                        <p:tgtEl>
+                                          <p:spTgt spid="9"/>
+                                        </p:tgtEl>
+                                        <p:attrNameLst>
+                                          <p:attrName>ppt_w</p:attrName>
+                                        </p:attrNameLst>
+                                      </p:cBhvr>
+                                      <p:tavLst>
+                                        <p:tav tm="0">
+                                          <p:val>
+                                            <p:strVal val="#ppt_w*0.70"/>
+                                          </p:val>
+                                        </p:tav>
+                                        <p:tav tm="100000">
+                                          <p:val>
+                                            <p:strVal val="#ppt_w"/>
+                                          </p:val>
+                                        </p:tav>
+                                      </p:tavLst>
+                                    </p:anim>
+                                    <p:anim calcmode="lin" valueType="num">
+                                      <p:cBhvr>
+                                        <p:cTn id="25" dur="1000" fill="hold"/>
+                                        <p:tgtEl>
+                                          <p:spTgt spid="9"/>
+                                        </p:tgtEl>
+                                        <p:attrNameLst>
+                                          <p:attrName>ppt_h</p:attrName>
+                                        </p:attrNameLst>
+                                      </p:cBhvr>
+                                      <p:tavLst>
+                                        <p:tav tm="0">
+                                          <p:val>
+                                            <p:strVal val="#ppt_h"/>
+                                          </p:val>
+                                        </p:tav>
+                                        <p:tav tm="100000">
+                                          <p:val>
+                                            <p:strVal val="#ppt_h"/>
+                                          </p:val>
+                                        </p:tav>
+                                      </p:tavLst>
+                                    </p:anim>
+                                    <p:animEffect transition="in" filter="fade">
+                                      <p:cBhvr>
+                                        <p:cTn id="26" dur="1000"/>
+                                        <p:tgtEl>
+                                          <p:spTgt spid="9"/>
+                                        </p:tgtEl>
+                                      </p:cBhvr>
+                                    </p:animEffect>
+                                  </p:childTnLst>
+                                </p:cTn>
+                              </p:par>
+                            </p:childTnLst>
+                          </p:cTn>
+                        </p:par>
+                      </p:childTnLst>
+                    </p:cTn>
+                  </p:par>
+                </p:childTnLst>
+              </p:cTn>
+              <p:prevCondLst>
+                <p:cond evt="onPrev" delay="0">
+                  <p:tgtEl>
+                    <p:sldTgt/>
+                  </p:tgtEl>
+                </p:cond>
+              </p:prevCondLst>
+              <p:nextCondLst>
+                <p:cond evt="onNext" delay="0">
+                  <p:tgtEl>
+                    <p:sldTgt/>
+                  </p:tgtEl>
+                </p:cond>
+              </p:nextCondLst>
+            </p:seq>
+          </p:childTnLst>
+        </p:cTn>
+      </p:par>
+    </p:tnLst>
+    <p:bldLst>
+      <p:bldP spid="9" grpId="0" animBg="1"/>
+      <p:bldP spid="11" grpId="0"/>
+      <p:bldP spid="12" grpId="0" animBg="1"/>
+    </p:bldLst>
+  </p:timing>
 </p:sld>
 </file>
 
@@ -15362,6 +18597,905 @@
       </p:grpSpPr>
       <p:sp>
         <p:nvSpPr>
+          <p:cNvPr id="8" name="Text 0"/>
+          <p:cNvSpPr/>
+          <p:nvPr/>
+        </p:nvSpPr>
+        <p:spPr>
+          <a:xfrm>
+            <a:off x="320040" y="128160"/>
+            <a:ext cx="11521080" cy="456840"/>
+          </a:xfrm>
+          <a:prstGeom prst="rect">
+            <a:avLst/>
+          </a:prstGeom>
+          <a:noFill/>
+          <a:ln w="0">
+            <a:noFill/>
+          </a:ln>
+        </p:spPr>
+        <p:style>
+          <a:lnRef idx="0">
+            <a:scrgbClr r="0" g="0" b="0"/>
+          </a:lnRef>
+          <a:fillRef idx="0">
+            <a:scrgbClr r="0" g="0" b="0"/>
+          </a:fillRef>
+          <a:effectRef idx="0">
+            <a:scrgbClr r="0" g="0" b="0"/>
+          </a:effectRef>
+          <a:fontRef idx="minor"/>
+        </p:style>
+        <p:txBody>
+          <a:bodyPr lIns="90000" tIns="45000" rIns="90000" bIns="45000" anchor="ctr">
+            <a:noAutofit/>
+          </a:bodyPr>
+          <a:lstStyle/>
+          <a:p>
+            <a:pPr algn="ctr" defTabSz="914400">
+              <a:lnSpc>
+                <a:spcPct val="100000"/>
+              </a:lnSpc>
+              <a:tabLst>
+                <a:tab pos="0" algn="l"/>
+              </a:tabLst>
+            </a:pPr>
+            <a:r>
+              <a:rPr lang="en-US" sz="2400" b="1" u="none" strike="noStrike">
+                <a:solidFill>
+                  <a:srgbClr val="2C3E50"/>
+                </a:solidFill>
+                <a:effectLst/>
+                <a:uFillTx/>
+                <a:latin typeface="Cambria"/>
+                <a:ea typeface="Cambria"/>
+              </a:rPr>
+              <a:t>How we measure disorder  —  UniProt · IUPred2 · ANCHOR2</a:t>
+            </a:r>
+            <a:endParaRPr lang="en-US" sz="2400" b="0" u="none" strike="noStrike">
+              <a:solidFill>
+                <a:srgbClr val="000000"/>
+              </a:solidFill>
+              <a:effectLst/>
+              <a:uFillTx/>
+              <a:latin typeface="Arial"/>
+            </a:endParaRPr>
+          </a:p>
+        </p:txBody>
+      </p:sp>
+      <p:sp>
+        <p:nvSpPr>
+          <p:cNvPr id="9" name="Text 1"/>
+          <p:cNvSpPr/>
+          <p:nvPr/>
+        </p:nvSpPr>
+        <p:spPr>
+          <a:xfrm>
+            <a:off x="320040" y="777240"/>
+            <a:ext cx="3702960" cy="1828440"/>
+          </a:xfrm>
+          <a:prstGeom prst="roundRect">
+            <a:avLst>
+              <a:gd name="adj" fmla="val 2500"/>
+            </a:avLst>
+          </a:prstGeom>
+          <a:solidFill>
+            <a:srgbClr val="FCEBD0"/>
+          </a:solidFill>
+          <a:ln w="16510">
+            <a:solidFill>
+              <a:srgbClr val="B9770E"/>
+            </a:solidFill>
+            <a:round/>
+          </a:ln>
+        </p:spPr>
+        <p:style>
+          <a:lnRef idx="0">
+            <a:scrgbClr r="0" g="0" b="0"/>
+          </a:lnRef>
+          <a:fillRef idx="0">
+            <a:scrgbClr r="0" g="0" b="0"/>
+          </a:fillRef>
+          <a:effectRef idx="0">
+            <a:scrgbClr r="0" g="0" b="0"/>
+          </a:effectRef>
+          <a:fontRef idx="minor"/>
+        </p:style>
+        <p:txBody>
+          <a:bodyPr lIns="101520" tIns="101520" rIns="101520" bIns="101520" anchor="t">
+            <a:noAutofit/>
+          </a:bodyPr>
+          <a:lstStyle/>
+          <a:p>
+            <a:pPr defTabSz="914400">
+              <a:lnSpc>
+                <a:spcPct val="100000"/>
+              </a:lnSpc>
+              <a:tabLst>
+                <a:tab pos="0" algn="l"/>
+              </a:tabLst>
+            </a:pPr>
+            <a:r>
+              <a:rPr lang="en-US" sz="1350" b="1" u="none" strike="noStrike" dirty="0">
+                <a:solidFill>
+                  <a:srgbClr val="B9770E"/>
+                </a:solidFill>
+                <a:effectLst/>
+                <a:uFillTx/>
+                <a:latin typeface="Calibri"/>
+              </a:rPr>
+              <a:t>UniProt — the annotation</a:t>
+            </a:r>
+            <a:endParaRPr lang="en-US" sz="1350" b="0" u="none" strike="noStrike" dirty="0">
+              <a:solidFill>
+                <a:srgbClr val="000000"/>
+              </a:solidFill>
+              <a:effectLst/>
+              <a:uFillTx/>
+              <a:latin typeface="Arial"/>
+            </a:endParaRPr>
+          </a:p>
+          <a:p>
+            <a:pPr defTabSz="914400">
+              <a:lnSpc>
+                <a:spcPct val="100000"/>
+              </a:lnSpc>
+              <a:tabLst>
+                <a:tab pos="0" algn="l"/>
+              </a:tabLst>
+            </a:pPr>
+            <a:r>
+              <a:rPr lang="en-US" sz="1000" b="0" i="1" u="none" strike="noStrike" dirty="0">
+                <a:solidFill>
+                  <a:srgbClr val="5A6B7B"/>
+                </a:solidFill>
+                <a:effectLst/>
+                <a:uFillTx/>
+                <a:latin typeface="Calibri"/>
+              </a:rPr>
+              <a:t>(the orange bands)</a:t>
+            </a:r>
+            <a:endParaRPr lang="en-US" sz="1000" b="0" u="none" strike="noStrike" dirty="0">
+              <a:solidFill>
+                <a:srgbClr val="000000"/>
+              </a:solidFill>
+              <a:effectLst/>
+              <a:uFillTx/>
+              <a:latin typeface="Arial"/>
+            </a:endParaRPr>
+          </a:p>
+          <a:p>
+            <a:pPr defTabSz="914400">
+              <a:lnSpc>
+                <a:spcPct val="100000"/>
+              </a:lnSpc>
+              <a:tabLst>
+                <a:tab pos="0" algn="l"/>
+              </a:tabLst>
+            </a:pPr>
+            <a:r>
+              <a:rPr lang="en-US" sz="1100" b="0" u="none" strike="noStrike" dirty="0">
+                <a:solidFill>
+                  <a:srgbClr val="2C3E50"/>
+                </a:solidFill>
+                <a:effectLst/>
+                <a:uFillTx/>
+                <a:latin typeface="Calibri"/>
+              </a:rPr>
+              <a:t>Curated, experimentally-supported disordered-region annotations. For Sororin: three IDRs (1–48, 72–142, 199–222) plus the folded C-terminal Sororin domain (230–252). These fixed blocks are the 'ground truth' shaded on the disorder map.</a:t>
+            </a:r>
+            <a:endParaRPr lang="en-US" sz="1100" b="0" u="none" strike="noStrike" dirty="0">
+              <a:solidFill>
+                <a:srgbClr val="000000"/>
+              </a:solidFill>
+              <a:effectLst/>
+              <a:uFillTx/>
+              <a:latin typeface="Arial"/>
+            </a:endParaRPr>
+          </a:p>
+        </p:txBody>
+      </p:sp>
+      <p:sp>
+        <p:nvSpPr>
+          <p:cNvPr id="10" name="Text 2"/>
+          <p:cNvSpPr/>
+          <p:nvPr/>
+        </p:nvSpPr>
+        <p:spPr>
+          <a:xfrm>
+            <a:off x="4206240" y="777240"/>
+            <a:ext cx="3702960" cy="1828440"/>
+          </a:xfrm>
+          <a:prstGeom prst="roundRect">
+            <a:avLst>
+              <a:gd name="adj" fmla="val 2500"/>
+            </a:avLst>
+          </a:prstGeom>
+          <a:solidFill>
+            <a:srgbClr val="F7DBDB"/>
+          </a:solidFill>
+          <a:ln w="16510">
+            <a:solidFill>
+              <a:srgbClr val="B2182B"/>
+            </a:solidFill>
+            <a:round/>
+          </a:ln>
+        </p:spPr>
+        <p:style>
+          <a:lnRef idx="0">
+            <a:scrgbClr r="0" g="0" b="0"/>
+          </a:lnRef>
+          <a:fillRef idx="0">
+            <a:scrgbClr r="0" g="0" b="0"/>
+          </a:fillRef>
+          <a:effectRef idx="0">
+            <a:scrgbClr r="0" g="0" b="0"/>
+          </a:effectRef>
+          <a:fontRef idx="minor"/>
+        </p:style>
+        <p:txBody>
+          <a:bodyPr lIns="101520" tIns="101520" rIns="101520" bIns="101520" anchor="t">
+            <a:noAutofit/>
+          </a:bodyPr>
+          <a:lstStyle/>
+          <a:p>
+            <a:pPr defTabSz="914400">
+              <a:lnSpc>
+                <a:spcPct val="100000"/>
+              </a:lnSpc>
+              <a:tabLst>
+                <a:tab pos="0" algn="l"/>
+              </a:tabLst>
+            </a:pPr>
+            <a:r>
+              <a:rPr lang="en-US" sz="1350" b="1" u="none" strike="noStrike">
+                <a:solidFill>
+                  <a:srgbClr val="B2182B"/>
+                </a:solidFill>
+                <a:effectLst/>
+                <a:uFillTx/>
+                <a:latin typeface="Calibri"/>
+              </a:rPr>
+              <a:t>IUPred2 — disorder prediction</a:t>
+            </a:r>
+            <a:endParaRPr lang="en-US" sz="1350" b="0" u="none" strike="noStrike">
+              <a:solidFill>
+                <a:srgbClr val="000000"/>
+              </a:solidFill>
+              <a:effectLst/>
+              <a:uFillTx/>
+              <a:latin typeface="Arial"/>
+            </a:endParaRPr>
+          </a:p>
+          <a:p>
+            <a:pPr defTabSz="914400">
+              <a:lnSpc>
+                <a:spcPct val="100000"/>
+              </a:lnSpc>
+              <a:tabLst>
+                <a:tab pos="0" algn="l"/>
+              </a:tabLst>
+            </a:pPr>
+            <a:r>
+              <a:rPr lang="en-US" sz="1000" b="0" i="1" u="none" strike="noStrike">
+                <a:solidFill>
+                  <a:srgbClr val="5A6B7B"/>
+                </a:solidFill>
+                <a:effectLst/>
+                <a:uFillTx/>
+                <a:latin typeface="Calibri"/>
+              </a:rPr>
+              <a:t>(the red curve)</a:t>
+            </a:r>
+            <a:endParaRPr lang="en-US" sz="1000" b="0" u="none" strike="noStrike">
+              <a:solidFill>
+                <a:srgbClr val="000000"/>
+              </a:solidFill>
+              <a:effectLst/>
+              <a:uFillTx/>
+              <a:latin typeface="Arial"/>
+            </a:endParaRPr>
+          </a:p>
+          <a:p>
+            <a:pPr defTabSz="914400">
+              <a:lnSpc>
+                <a:spcPct val="100000"/>
+              </a:lnSpc>
+              <a:tabLst>
+                <a:tab pos="0" algn="l"/>
+              </a:tabLst>
+            </a:pPr>
+            <a:r>
+              <a:rPr lang="en-US" sz="1100" b="0" u="none" strike="noStrike">
+                <a:solidFill>
+                  <a:srgbClr val="2C3E50"/>
+                </a:solidFill>
+                <a:effectLst/>
+                <a:uFillTx/>
+                <a:latin typeface="Calibri"/>
+              </a:rPr>
+              <a:t>A per-residue score from 0 to 1; &gt; 0.5 = predicted disordered. 61.5% of Sororin scores above 0.5. Sequence-only and energy-based — no structure or homology needed.</a:t>
+            </a:r>
+            <a:endParaRPr lang="en-US" sz="1100" b="0" u="none" strike="noStrike">
+              <a:solidFill>
+                <a:srgbClr val="000000"/>
+              </a:solidFill>
+              <a:effectLst/>
+              <a:uFillTx/>
+              <a:latin typeface="Arial"/>
+            </a:endParaRPr>
+          </a:p>
+        </p:txBody>
+      </p:sp>
+      <p:sp>
+        <p:nvSpPr>
+          <p:cNvPr id="11" name="Text 3"/>
+          <p:cNvSpPr/>
+          <p:nvPr/>
+        </p:nvSpPr>
+        <p:spPr>
+          <a:xfrm>
+            <a:off x="8092440" y="777240"/>
+            <a:ext cx="3748680" cy="1828440"/>
+          </a:xfrm>
+          <a:prstGeom prst="roundRect">
+            <a:avLst>
+              <a:gd name="adj" fmla="val 2500"/>
+            </a:avLst>
+          </a:prstGeom>
+          <a:solidFill>
+            <a:srgbClr val="DCE7F3"/>
+          </a:solidFill>
+          <a:ln w="16510">
+            <a:solidFill>
+              <a:srgbClr val="2166AC"/>
+            </a:solidFill>
+            <a:round/>
+          </a:ln>
+        </p:spPr>
+        <p:style>
+          <a:lnRef idx="0">
+            <a:scrgbClr r="0" g="0" b="0"/>
+          </a:lnRef>
+          <a:fillRef idx="0">
+            <a:scrgbClr r="0" g="0" b="0"/>
+          </a:fillRef>
+          <a:effectRef idx="0">
+            <a:scrgbClr r="0" g="0" b="0"/>
+          </a:effectRef>
+          <a:fontRef idx="minor"/>
+        </p:style>
+        <p:txBody>
+          <a:bodyPr lIns="101520" tIns="101520" rIns="101520" bIns="101520" anchor="t">
+            <a:noAutofit/>
+          </a:bodyPr>
+          <a:lstStyle/>
+          <a:p>
+            <a:pPr defTabSz="914400">
+              <a:lnSpc>
+                <a:spcPct val="100000"/>
+              </a:lnSpc>
+              <a:tabLst>
+                <a:tab pos="0" algn="l"/>
+              </a:tabLst>
+            </a:pPr>
+            <a:r>
+              <a:rPr lang="en-US" sz="1350" b="1" u="none" strike="noStrike">
+                <a:solidFill>
+                  <a:srgbClr val="2166AC"/>
+                </a:solidFill>
+                <a:effectLst/>
+                <a:uFillTx/>
+                <a:latin typeface="Calibri"/>
+              </a:rPr>
+              <a:t>ANCHOR2 — disordered binding</a:t>
+            </a:r>
+            <a:endParaRPr lang="en-US" sz="1350" b="0" u="none" strike="noStrike">
+              <a:solidFill>
+                <a:srgbClr val="000000"/>
+              </a:solidFill>
+              <a:effectLst/>
+              <a:uFillTx/>
+              <a:latin typeface="Arial"/>
+            </a:endParaRPr>
+          </a:p>
+          <a:p>
+            <a:pPr defTabSz="914400">
+              <a:lnSpc>
+                <a:spcPct val="100000"/>
+              </a:lnSpc>
+              <a:tabLst>
+                <a:tab pos="0" algn="l"/>
+              </a:tabLst>
+            </a:pPr>
+            <a:r>
+              <a:rPr lang="en-US" sz="1000" b="0" i="1" u="none" strike="noStrike">
+                <a:solidFill>
+                  <a:srgbClr val="5A6B7B"/>
+                </a:solidFill>
+                <a:effectLst/>
+                <a:uFillTx/>
+                <a:latin typeface="Calibri"/>
+              </a:rPr>
+              <a:t>(the blue curve)</a:t>
+            </a:r>
+            <a:endParaRPr lang="en-US" sz="1000" b="0" u="none" strike="noStrike">
+              <a:solidFill>
+                <a:srgbClr val="000000"/>
+              </a:solidFill>
+              <a:effectLst/>
+              <a:uFillTx/>
+              <a:latin typeface="Arial"/>
+            </a:endParaRPr>
+          </a:p>
+          <a:p>
+            <a:pPr defTabSz="914400">
+              <a:lnSpc>
+                <a:spcPct val="100000"/>
+              </a:lnSpc>
+              <a:tabLst>
+                <a:tab pos="0" algn="l"/>
+              </a:tabLst>
+            </a:pPr>
+            <a:r>
+              <a:rPr lang="en-US" sz="1100" b="0" u="none" strike="noStrike">
+                <a:solidFill>
+                  <a:srgbClr val="2C3E50"/>
+                </a:solidFill>
+                <a:effectLst/>
+                <a:uFillTx/>
+                <a:latin typeface="Calibri"/>
+              </a:rPr>
+              <a:t>Flags disordered stretches that can still bind a partner (fold-upon-binding) — 'binding-competent disorder.' It marks where the floppy chain actually does its interacting, not just where it is floppy.</a:t>
+            </a:r>
+            <a:endParaRPr lang="en-US" sz="1100" b="0" u="none" strike="noStrike">
+              <a:solidFill>
+                <a:srgbClr val="000000"/>
+              </a:solidFill>
+              <a:effectLst/>
+              <a:uFillTx/>
+              <a:latin typeface="Arial"/>
+            </a:endParaRPr>
+          </a:p>
+        </p:txBody>
+      </p:sp>
+      <p:sp>
+        <p:nvSpPr>
+          <p:cNvPr id="12" name="Text 4"/>
+          <p:cNvSpPr/>
+          <p:nvPr/>
+        </p:nvSpPr>
+        <p:spPr>
+          <a:xfrm>
+            <a:off x="320040" y="2788920"/>
+            <a:ext cx="5806080" cy="2239920"/>
+          </a:xfrm>
+          <a:prstGeom prst="roundRect">
+            <a:avLst>
+              <a:gd name="adj" fmla="val 2041"/>
+            </a:avLst>
+          </a:prstGeom>
+          <a:solidFill>
+            <a:srgbClr val="F4F0F7"/>
+          </a:solidFill>
+          <a:ln w="12700">
+            <a:solidFill>
+              <a:srgbClr val="762A83"/>
+            </a:solidFill>
+            <a:round/>
+          </a:ln>
+        </p:spPr>
+        <p:style>
+          <a:lnRef idx="0">
+            <a:scrgbClr r="0" g="0" b="0"/>
+          </a:lnRef>
+          <a:fillRef idx="0">
+            <a:scrgbClr r="0" g="0" b="0"/>
+          </a:fillRef>
+          <a:effectRef idx="0">
+            <a:scrgbClr r="0" g="0" b="0"/>
+          </a:effectRef>
+          <a:fontRef idx="minor"/>
+        </p:style>
+        <p:txBody>
+          <a:bodyPr lIns="114480" tIns="114480" rIns="114480" bIns="114480" anchor="t">
+            <a:noAutofit/>
+          </a:bodyPr>
+          <a:lstStyle/>
+          <a:p>
+            <a:pPr defTabSz="914400">
+              <a:lnSpc>
+                <a:spcPct val="100000"/>
+              </a:lnSpc>
+              <a:tabLst>
+                <a:tab pos="0" algn="l"/>
+              </a:tabLst>
+            </a:pPr>
+            <a:r>
+              <a:rPr lang="en-US" sz="1050" b="1" u="none" strike="noStrike">
+                <a:solidFill>
+                  <a:srgbClr val="762A83"/>
+                </a:solidFill>
+                <a:effectLst/>
+                <a:uFillTx/>
+                <a:latin typeface="Calibri"/>
+              </a:rPr>
+              <a:t>how IUPred2 works (reference):  </a:t>
+            </a:r>
+            <a:endParaRPr lang="en-US" sz="1050" b="0" u="none" strike="noStrike">
+              <a:solidFill>
+                <a:srgbClr val="000000"/>
+              </a:solidFill>
+              <a:effectLst/>
+              <a:uFillTx/>
+              <a:latin typeface="Arial"/>
+            </a:endParaRPr>
+          </a:p>
+          <a:p>
+            <a:pPr defTabSz="914400">
+              <a:lnSpc>
+                <a:spcPct val="100000"/>
+              </a:lnSpc>
+              <a:tabLst>
+                <a:tab pos="0" algn="l"/>
+              </a:tabLst>
+            </a:pPr>
+            <a:r>
+              <a:rPr lang="en-US" sz="1050" b="0" u="none" strike="noStrike">
+                <a:solidFill>
+                  <a:srgbClr val="2C3E50"/>
+                </a:solidFill>
+                <a:effectLst/>
+                <a:uFillTx/>
+                <a:latin typeface="Calibri"/>
+              </a:rPr>
+              <a:t>For each residue it estimates the stabilising pairwise contact energy that residue could gain by folding into a compact structure, from a statistical 20×20 amino-acid energy matrix applied over the local sequence composition:</a:t>
+            </a:r>
+            <a:endParaRPr lang="en-US" sz="1050" b="0" u="none" strike="noStrike">
+              <a:solidFill>
+                <a:srgbClr val="000000"/>
+              </a:solidFill>
+              <a:effectLst/>
+              <a:uFillTx/>
+              <a:latin typeface="Arial"/>
+            </a:endParaRPr>
+          </a:p>
+          <a:p>
+            <a:pPr defTabSz="914400">
+              <a:lnSpc>
+                <a:spcPct val="100000"/>
+              </a:lnSpc>
+              <a:tabLst>
+                <a:tab pos="0" algn="l"/>
+              </a:tabLst>
+            </a:pPr>
+            <a:r>
+              <a:rPr lang="en-US" sz="1100" b="1" i="1" u="none" strike="noStrike">
+                <a:solidFill>
+                  <a:srgbClr val="2C3E50"/>
+                </a:solidFill>
+                <a:effectLst/>
+                <a:uFillTx/>
+                <a:latin typeface="Calibri"/>
+              </a:rPr>
+              <a:t>E(i)  ≈  Σ over pairs (a,b)  of  M(a,b) · cₐ · c_b </a:t>
+            </a:r>
+            <a:endParaRPr lang="en-US" sz="1100" b="0" u="none" strike="noStrike">
+              <a:solidFill>
+                <a:srgbClr val="000000"/>
+              </a:solidFill>
+              <a:effectLst/>
+              <a:uFillTx/>
+              <a:latin typeface="Arial"/>
+            </a:endParaRPr>
+          </a:p>
+          <a:p>
+            <a:pPr defTabSz="914400">
+              <a:lnSpc>
+                <a:spcPct val="100000"/>
+              </a:lnSpc>
+              <a:tabLst>
+                <a:tab pos="0" algn="l"/>
+              </a:tabLst>
+            </a:pPr>
+            <a:r>
+              <a:rPr lang="en-US" sz="1050" b="0" u="none" strike="noStrike">
+                <a:solidFill>
+                  <a:srgbClr val="2C3E50"/>
+                </a:solidFill>
+                <a:effectLst/>
+                <a:uFillTx/>
+                <a:latin typeface="Calibri"/>
+              </a:rPr>
+              <a:t>Residues that cannot gather enough stabilising energy to fold are predicted disordered (high score). It is a mean-field energy estimate from sequence — the physics-flavoured part.</a:t>
+            </a:r>
+            <a:endParaRPr lang="en-US" sz="1050" b="0" u="none" strike="noStrike">
+              <a:solidFill>
+                <a:srgbClr val="000000"/>
+              </a:solidFill>
+              <a:effectLst/>
+              <a:uFillTx/>
+              <a:latin typeface="Arial"/>
+            </a:endParaRPr>
+          </a:p>
+        </p:txBody>
+      </p:sp>
+      <p:sp>
+        <p:nvSpPr>
+          <p:cNvPr id="13" name="Text 5"/>
+          <p:cNvSpPr/>
+          <p:nvPr/>
+        </p:nvSpPr>
+        <p:spPr>
+          <a:xfrm>
+            <a:off x="6355080" y="2788920"/>
+            <a:ext cx="5486040" cy="2239920"/>
+          </a:xfrm>
+          <a:prstGeom prst="roundRect">
+            <a:avLst>
+              <a:gd name="adj" fmla="val 2041"/>
+            </a:avLst>
+          </a:prstGeom>
+          <a:solidFill>
+            <a:srgbClr val="F4F0F7"/>
+          </a:solidFill>
+          <a:ln w="12700">
+            <a:solidFill>
+              <a:srgbClr val="762A83"/>
+            </a:solidFill>
+            <a:round/>
+          </a:ln>
+        </p:spPr>
+        <p:style>
+          <a:lnRef idx="0">
+            <a:scrgbClr r="0" g="0" b="0"/>
+          </a:lnRef>
+          <a:fillRef idx="0">
+            <a:scrgbClr r="0" g="0" b="0"/>
+          </a:fillRef>
+          <a:effectRef idx="0">
+            <a:scrgbClr r="0" g="0" b="0"/>
+          </a:effectRef>
+          <a:fontRef idx="minor"/>
+        </p:style>
+        <p:txBody>
+          <a:bodyPr lIns="114480" tIns="114480" rIns="114480" bIns="114480" anchor="t">
+            <a:noAutofit/>
+          </a:bodyPr>
+          <a:lstStyle/>
+          <a:p>
+            <a:pPr defTabSz="914400">
+              <a:lnSpc>
+                <a:spcPct val="100000"/>
+              </a:lnSpc>
+              <a:tabLst>
+                <a:tab pos="0" algn="l"/>
+              </a:tabLst>
+            </a:pPr>
+            <a:r>
+              <a:rPr lang="en-US" sz="1050" b="1" u="none" strike="noStrike">
+                <a:solidFill>
+                  <a:srgbClr val="762A83"/>
+                </a:solidFill>
+                <a:effectLst/>
+                <a:uFillTx/>
+                <a:latin typeface="Calibri"/>
+              </a:rPr>
+              <a:t>how ANCHOR2 works (reference):  </a:t>
+            </a:r>
+            <a:endParaRPr lang="en-US" sz="1050" b="0" u="none" strike="noStrike">
+              <a:solidFill>
+                <a:srgbClr val="000000"/>
+              </a:solidFill>
+              <a:effectLst/>
+              <a:uFillTx/>
+              <a:latin typeface="Arial"/>
+            </a:endParaRPr>
+          </a:p>
+          <a:p>
+            <a:pPr defTabSz="914400">
+              <a:lnSpc>
+                <a:spcPct val="100000"/>
+              </a:lnSpc>
+              <a:tabLst>
+                <a:tab pos="0" algn="l"/>
+              </a:tabLst>
+            </a:pPr>
+            <a:r>
+              <a:rPr lang="en-US" sz="1050" b="0" u="none" strike="noStrike">
+                <a:solidFill>
+                  <a:srgbClr val="2C3E50"/>
+                </a:solidFill>
+                <a:effectLst/>
+                <a:uFillTx/>
+                <a:latin typeface="Calibri"/>
+              </a:rPr>
+              <a:t>It asks a second energy question: a residue that cannot fold on its own — could it gain enough favourable energy by binding a generic globular partner? If yes, it is flagged as a disordered binding region.</a:t>
+            </a:r>
+            <a:endParaRPr lang="en-US" sz="1050" b="0" u="none" strike="noStrike">
+              <a:solidFill>
+                <a:srgbClr val="000000"/>
+              </a:solidFill>
+              <a:effectLst/>
+              <a:uFillTx/>
+              <a:latin typeface="Arial"/>
+            </a:endParaRPr>
+          </a:p>
+          <a:p>
+            <a:pPr defTabSz="914400">
+              <a:lnSpc>
+                <a:spcPct val="100000"/>
+              </a:lnSpc>
+              <a:tabLst>
+                <a:tab pos="0" algn="l"/>
+              </a:tabLst>
+            </a:pPr>
+            <a:r>
+              <a:rPr lang="en-US" sz="1050" b="1" i="1" u="none" strike="noStrike">
+                <a:solidFill>
+                  <a:srgbClr val="2C3E50"/>
+                </a:solidFill>
+                <a:effectLst/>
+                <a:uFillTx/>
+                <a:latin typeface="Calibri"/>
+              </a:rPr>
+              <a:t>disordered on its own  +  energetically favourable to bind  →  binding-competent disorder</a:t>
+            </a:r>
+            <a:endParaRPr lang="en-US" sz="1050" b="0" u="none" strike="noStrike">
+              <a:solidFill>
+                <a:srgbClr val="000000"/>
+              </a:solidFill>
+              <a:effectLst/>
+              <a:uFillTx/>
+              <a:latin typeface="Arial"/>
+            </a:endParaRPr>
+          </a:p>
+          <a:p>
+            <a:pPr defTabSz="914400">
+              <a:lnSpc>
+                <a:spcPct val="100000"/>
+              </a:lnSpc>
+              <a:tabLst>
+                <a:tab pos="0" algn="l"/>
+              </a:tabLst>
+            </a:pPr>
+            <a:r>
+              <a:rPr lang="en-US" sz="1050" b="0" u="none" strike="noStrike">
+                <a:solidFill>
+                  <a:srgbClr val="2C3E50"/>
+                </a:solidFill>
+                <a:effectLst/>
+                <a:uFillTx/>
+                <a:latin typeface="Calibri"/>
+              </a:rPr>
+              <a:t>This is how a floppy region that looks 'structureless' is still identified as a functional interaction site (e.g. the KEN box, the phospho-cluster).</a:t>
+            </a:r>
+            <a:endParaRPr lang="en-US" sz="1050" b="0" u="none" strike="noStrike">
+              <a:solidFill>
+                <a:srgbClr val="000000"/>
+              </a:solidFill>
+              <a:effectLst/>
+              <a:uFillTx/>
+              <a:latin typeface="Arial"/>
+            </a:endParaRPr>
+          </a:p>
+        </p:txBody>
+      </p:sp>
+      <p:sp>
+        <p:nvSpPr>
+          <p:cNvPr id="14" name="Text 6"/>
+          <p:cNvSpPr/>
+          <p:nvPr/>
+        </p:nvSpPr>
+        <p:spPr>
+          <a:xfrm>
+            <a:off x="320040" y="5257800"/>
+            <a:ext cx="11521080" cy="1096920"/>
+          </a:xfrm>
+          <a:prstGeom prst="rect">
+            <a:avLst/>
+          </a:prstGeom>
+          <a:noFill/>
+          <a:ln w="0">
+            <a:noFill/>
+          </a:ln>
+        </p:spPr>
+        <p:style>
+          <a:lnRef idx="0">
+            <a:scrgbClr r="0" g="0" b="0"/>
+          </a:lnRef>
+          <a:fillRef idx="0">
+            <a:scrgbClr r="0" g="0" b="0"/>
+          </a:fillRef>
+          <a:effectRef idx="0">
+            <a:scrgbClr r="0" g="0" b="0"/>
+          </a:effectRef>
+          <a:fontRef idx="minor"/>
+        </p:style>
+        <p:txBody>
+          <a:bodyPr lIns="90000" tIns="45000" rIns="90000" bIns="45000" anchor="t">
+            <a:noAutofit/>
+          </a:bodyPr>
+          <a:lstStyle/>
+          <a:p>
+            <a:pPr defTabSz="914400">
+              <a:lnSpc>
+                <a:spcPct val="100000"/>
+              </a:lnSpc>
+              <a:tabLst>
+                <a:tab pos="0" algn="l"/>
+              </a:tabLst>
+            </a:pPr>
+            <a:r>
+              <a:rPr lang="en-US" sz="1100" b="1" u="none" strike="noStrike" dirty="0">
+                <a:solidFill>
+                  <a:srgbClr val="1A7A34"/>
+                </a:solidFill>
+                <a:effectLst/>
+                <a:uFillTx/>
+                <a:latin typeface="Calibri"/>
+                <a:ea typeface="Calibri"/>
+              </a:rPr>
+              <a:t>How obtained:  </a:t>
+            </a:r>
+            <a:r>
+              <a:rPr lang="en-US" sz="1100" b="0" u="none" strike="noStrike" dirty="0">
+                <a:solidFill>
+                  <a:srgbClr val="5A6B7B"/>
+                </a:solidFill>
+                <a:effectLst/>
+                <a:uFillTx/>
+                <a:latin typeface="Calibri"/>
+                <a:ea typeface="Calibri"/>
+              </a:rPr>
+              <a:t>UniProt REST API (region annotations, script 01)  →  IUPred2A reference implementation + energy matrices, downloaded and run locally (script 03)  →  per-residue disorder + binding profile  →  the disorder map. </a:t>
+            </a:r>
+            <a:endParaRPr lang="en-US" sz="1100" b="0" u="none" strike="noStrike" dirty="0">
+              <a:solidFill>
+                <a:srgbClr val="000000"/>
+              </a:solidFill>
+              <a:effectLst/>
+              <a:uFillTx/>
+              <a:latin typeface="Arial"/>
+            </a:endParaRPr>
+          </a:p>
+        </p:txBody>
+      </p:sp>
+    </p:spTree>
+  </p:cSld>
+  <p:clrMapOvr>
+    <a:masterClrMapping/>
+  </p:clrMapOvr>
+</p:sld>
+</file>
+
+<file path=ppt/slides/slide9.xml><?xml version="1.0" encoding="utf-8"?>
+<p:sld xmlns:a="http://schemas.openxmlformats.org/drawingml/2006/main" xmlns:r="http://schemas.openxmlformats.org/officeDocument/2006/relationships" xmlns:p="http://schemas.openxmlformats.org/presentationml/2006/main">
+  <p:cSld>
+    <p:bg>
+      <p:bgPr>
+        <a:solidFill>
+          <a:srgbClr val="FFFFFF"/>
+        </a:solidFill>
+        <a:effectLst/>
+      </p:bgPr>
+    </p:bg>
+    <p:spTree>
+      <p:nvGrpSpPr>
+        <p:cNvPr id="1" name=""/>
+        <p:cNvGrpSpPr/>
+        <p:nvPr/>
+      </p:nvGrpSpPr>
+      <p:grpSpPr>
+        <a:xfrm>
+          <a:off x="0" y="0"/>
+          <a:ext cx="0" cy="0"/>
+          <a:chOff x="0" y="0"/>
+          <a:chExt cx="0" cy="0"/>
+        </a:xfrm>
+      </p:grpSpPr>
+      <p:sp>
+        <p:nvSpPr>
           <p:cNvPr id="50" name="Text 0"/>
           <p:cNvSpPr/>
           <p:nvPr/>
@@ -15428,202 +19562,244 @@
           </a:p>
         </p:txBody>
       </p:sp>
-      <p:pic>
-        <p:nvPicPr>
-          <p:cNvPr id="51" name="a_af" descr="/tmp/assets/af_crop.png"/>
-          <p:cNvPicPr/>
+      <p:grpSp>
+        <p:nvGrpSpPr>
+          <p:cNvPr id="3" name="Group 2">
+            <a:extLst>
+              <a:ext uri="{FF2B5EF4-FFF2-40B4-BE49-F238E27FC236}">
+                <a16:creationId xmlns:a16="http://schemas.microsoft.com/office/drawing/2014/main" id="{EFD8EA6D-D23F-825F-141B-CD8B7CDBCBAC}"/>
+              </a:ext>
+            </a:extLst>
+          </p:cNvPr>
+          <p:cNvGrpSpPr/>
           <p:nvPr/>
-        </p:nvPicPr>
-        <p:blipFill>
-          <a:blip r:embed="rId3"/>
-          <a:stretch/>
-        </p:blipFill>
-        <p:spPr>
+        </p:nvGrpSpPr>
+        <p:grpSpPr>
           <a:xfrm>
-            <a:off x="914400" y="1234440"/>
-            <a:ext cx="2631960" cy="3565800"/>
+            <a:off x="8321040" y="1083600"/>
+            <a:ext cx="3382920" cy="4845960"/>
+            <a:chOff x="548640" y="1234440"/>
+            <a:chExt cx="3382920" cy="4845960"/>
           </a:xfrm>
-          <a:prstGeom prst="rect">
-            <a:avLst/>
-          </a:prstGeom>
-          <a:noFill/>
-          <a:ln w="0">
+        </p:grpSpPr>
+        <p:pic>
+          <p:nvPicPr>
+            <p:cNvPr id="51" name="a_af" descr="/tmp/assets/af_crop.png"/>
+            <p:cNvPicPr/>
+            <p:nvPr/>
+          </p:nvPicPr>
+          <p:blipFill>
+            <a:blip r:embed="rId3"/>
+            <a:stretch/>
+          </p:blipFill>
+          <p:spPr>
+            <a:xfrm>
+              <a:off x="914400" y="1234440"/>
+              <a:ext cx="2631960" cy="3565800"/>
+            </a:xfrm>
+            <a:prstGeom prst="rect">
+              <a:avLst/>
+            </a:prstGeom>
             <a:noFill/>
-          </a:ln>
-        </p:spPr>
-      </p:pic>
-      <p:sp>
-        <p:nvSpPr>
-          <p:cNvPr id="52" name="Text 1"/>
-          <p:cNvSpPr/>
-          <p:nvPr/>
-        </p:nvSpPr>
-        <p:spPr>
-          <a:xfrm>
-            <a:off x="548640" y="4892040"/>
-            <a:ext cx="3382920" cy="1188360"/>
-          </a:xfrm>
-          <a:prstGeom prst="rect">
-            <a:avLst/>
-          </a:prstGeom>
-          <a:noFill/>
-          <a:ln w="0">
+            <a:ln w="0">
+              <a:noFill/>
+            </a:ln>
+          </p:spPr>
+        </p:pic>
+        <p:sp>
+          <p:nvSpPr>
+            <p:cNvPr id="52" name="Text 1"/>
+            <p:cNvSpPr/>
+            <p:nvPr/>
+          </p:nvSpPr>
+          <p:spPr>
+            <a:xfrm>
+              <a:off x="548640" y="4892040"/>
+              <a:ext cx="3382920" cy="1188360"/>
+            </a:xfrm>
+            <a:prstGeom prst="rect">
+              <a:avLst/>
+            </a:prstGeom>
             <a:noFill/>
-          </a:ln>
-        </p:spPr>
-        <p:style>
-          <a:lnRef idx="0">
-            <a:scrgbClr r="0" g="0" b="0"/>
-          </a:lnRef>
-          <a:fillRef idx="0">
-            <a:scrgbClr r="0" g="0" b="0"/>
-          </a:fillRef>
-          <a:effectRef idx="0">
-            <a:scrgbClr r="0" g="0" b="0"/>
-          </a:effectRef>
-          <a:fontRef idx="minor"/>
-        </p:style>
-        <p:txBody>
-          <a:bodyPr lIns="90000" tIns="45000" rIns="90000" bIns="45000" anchor="ctr">
-            <a:noAutofit/>
-          </a:bodyPr>
-          <a:lstStyle/>
-          <a:p>
-            <a:pPr defTabSz="914400">
-              <a:lnSpc>
-                <a:spcPct val="100000"/>
-              </a:lnSpc>
-              <a:tabLst>
-                <a:tab pos="0" algn="l"/>
-              </a:tabLst>
-            </a:pPr>
-            <a:r>
-              <a:rPr lang="en-US" sz="1200" b="0" u="none" strike="noStrike">
-                <a:solidFill>
-                  <a:srgbClr val="2C3E50"/>
+            <a:ln w="0">
+              <a:noFill/>
+            </a:ln>
+          </p:spPr>
+          <p:style>
+            <a:lnRef idx="0">
+              <a:scrgbClr r="0" g="0" b="0"/>
+            </a:lnRef>
+            <a:fillRef idx="0">
+              <a:scrgbClr r="0" g="0" b="0"/>
+            </a:fillRef>
+            <a:effectRef idx="0">
+              <a:scrgbClr r="0" g="0" b="0"/>
+            </a:effectRef>
+            <a:fontRef idx="minor"/>
+          </p:style>
+          <p:txBody>
+            <a:bodyPr lIns="90000" tIns="45000" rIns="90000" bIns="45000" anchor="ctr">
+              <a:noAutofit/>
+            </a:bodyPr>
+            <a:lstStyle/>
+            <a:p>
+              <a:pPr defTabSz="914400">
+                <a:lnSpc>
+                  <a:spcPct val="100000"/>
+                </a:lnSpc>
+                <a:tabLst>
+                  <a:tab pos="0" algn="l"/>
+                </a:tabLst>
+              </a:pPr>
+              <a:r>
+                <a:rPr lang="en-US" sz="1200" b="0" u="none" strike="noStrike">
+                  <a:solidFill>
+                    <a:srgbClr val="2C3E50"/>
+                  </a:solidFill>
+                  <a:effectLst/>
+                  <a:uFillTx/>
+                  <a:latin typeface="Calibri"/>
+                  <a:ea typeface="Calibri"/>
+                </a:rPr>
+                <a:t>AlphaFold 3D model — a floppy, extended chain with almost no fixed structure (one short helix = the folded C-terminus).</a:t>
+              </a:r>
+              <a:endParaRPr lang="en-US" sz="1200" b="0" u="none" strike="noStrike">
+                <a:solidFill>
+                  <a:srgbClr val="000000"/>
                 </a:solidFill>
                 <a:effectLst/>
                 <a:uFillTx/>
-                <a:latin typeface="Calibri"/>
-                <a:ea typeface="Calibri"/>
-              </a:rPr>
-              <a:t>AlphaFold 3D model — a floppy, extended chain with almost no fixed structure (one short helix = the folded C-terminus).</a:t>
-            </a:r>
-            <a:endParaRPr lang="en-US" sz="1200" b="0" u="none" strike="noStrike">
-              <a:solidFill>
-                <a:srgbClr val="000000"/>
-              </a:solidFill>
-              <a:effectLst/>
-              <a:uFillTx/>
-              <a:latin typeface="Arial"/>
-            </a:endParaRPr>
-          </a:p>
-        </p:txBody>
-      </p:sp>
-      <p:pic>
-        <p:nvPicPr>
-          <p:cNvPr id="53" name="a_disorder" descr="/tmp/assets/disorder_crop.png"/>
-          <p:cNvPicPr/>
+                <a:latin typeface="Arial"/>
+              </a:endParaRPr>
+            </a:p>
+          </p:txBody>
+        </p:sp>
+      </p:grpSp>
+      <p:grpSp>
+        <p:nvGrpSpPr>
+          <p:cNvPr id="2" name="Group 1">
+            <a:extLst>
+              <a:ext uri="{FF2B5EF4-FFF2-40B4-BE49-F238E27FC236}">
+                <a16:creationId xmlns:a16="http://schemas.microsoft.com/office/drawing/2014/main" id="{311E238E-9C79-74F0-97EE-7DDE6F755C51}"/>
+              </a:ext>
+            </a:extLst>
+          </p:cNvPr>
+          <p:cNvGrpSpPr/>
           <p:nvPr/>
-        </p:nvPicPr>
-        <p:blipFill>
-          <a:blip r:embed="rId4"/>
-          <a:stretch/>
-        </p:blipFill>
-        <p:spPr>
+        </p:nvGrpSpPr>
+        <p:grpSpPr>
           <a:xfrm>
-            <a:off x="4297680" y="1371600"/>
-            <a:ext cx="7406280" cy="4083480"/>
+            <a:off x="548640" y="983160"/>
+            <a:ext cx="7406280" cy="4891680"/>
+            <a:chOff x="4297680" y="1371600"/>
+            <a:chExt cx="7406280" cy="4891680"/>
           </a:xfrm>
-          <a:prstGeom prst="rect">
-            <a:avLst/>
-          </a:prstGeom>
-          <a:noFill/>
-          <a:ln w="0">
+        </p:grpSpPr>
+        <p:pic>
+          <p:nvPicPr>
+            <p:cNvPr id="53" name="a_disorder" descr="/tmp/assets/disorder_crop.png"/>
+            <p:cNvPicPr/>
+            <p:nvPr/>
+          </p:nvPicPr>
+          <p:blipFill>
+            <a:blip r:embed="rId4"/>
+            <a:stretch/>
+          </p:blipFill>
+          <p:spPr>
+            <a:xfrm>
+              <a:off x="4297680" y="1371600"/>
+              <a:ext cx="7406280" cy="4083480"/>
+            </a:xfrm>
+            <a:prstGeom prst="rect">
+              <a:avLst/>
+            </a:prstGeom>
             <a:noFill/>
-          </a:ln>
-        </p:spPr>
-      </p:pic>
-      <p:sp>
-        <p:nvSpPr>
-          <p:cNvPr id="54" name="Text 2"/>
-          <p:cNvSpPr/>
-          <p:nvPr/>
-        </p:nvSpPr>
-        <p:spPr>
-          <a:xfrm>
-            <a:off x="4297680" y="5623560"/>
-            <a:ext cx="7406280" cy="639720"/>
-          </a:xfrm>
-          <a:prstGeom prst="rect">
-            <a:avLst/>
-          </a:prstGeom>
-          <a:noFill/>
-          <a:ln w="0">
+            <a:ln w="0">
+              <a:noFill/>
+            </a:ln>
+          </p:spPr>
+        </p:pic>
+        <p:sp>
+          <p:nvSpPr>
+            <p:cNvPr id="54" name="Text 2"/>
+            <p:cNvSpPr/>
+            <p:nvPr/>
+          </p:nvSpPr>
+          <p:spPr>
+            <a:xfrm>
+              <a:off x="4297680" y="5623560"/>
+              <a:ext cx="7406280" cy="639720"/>
+            </a:xfrm>
+            <a:prstGeom prst="rect">
+              <a:avLst/>
+            </a:prstGeom>
             <a:noFill/>
-          </a:ln>
-        </p:spPr>
-        <p:style>
-          <a:lnRef idx="0">
-            <a:scrgbClr r="0" g="0" b="0"/>
-          </a:lnRef>
-          <a:fillRef idx="0">
-            <a:scrgbClr r="0" g="0" b="0"/>
-          </a:fillRef>
-          <a:effectRef idx="0">
-            <a:scrgbClr r="0" g="0" b="0"/>
-          </a:effectRef>
-          <a:fontRef idx="minor"/>
-        </p:style>
-        <p:txBody>
-          <a:bodyPr lIns="90000" tIns="45000" rIns="90000" bIns="45000" anchor="ctr">
-            <a:noAutofit/>
-          </a:bodyPr>
-          <a:lstStyle/>
-          <a:p>
-            <a:pPr defTabSz="914400">
-              <a:lnSpc>
-                <a:spcPct val="100000"/>
-              </a:lnSpc>
-              <a:tabLst>
-                <a:tab pos="0" algn="l"/>
-              </a:tabLst>
-            </a:pPr>
-            <a:r>
-              <a:rPr lang="en-US" sz="1150" b="0" i="1" u="none" strike="noStrike" dirty="0" err="1">
-                <a:solidFill>
-                  <a:srgbClr val="5A6B7B"/>
+            <a:ln w="0">
+              <a:noFill/>
+            </a:ln>
+          </p:spPr>
+          <p:style>
+            <a:lnRef idx="0">
+              <a:scrgbClr r="0" g="0" b="0"/>
+            </a:lnRef>
+            <a:fillRef idx="0">
+              <a:scrgbClr r="0" g="0" b="0"/>
+            </a:fillRef>
+            <a:effectRef idx="0">
+              <a:scrgbClr r="0" g="0" b="0"/>
+            </a:effectRef>
+            <a:fontRef idx="minor"/>
+          </p:style>
+          <p:txBody>
+            <a:bodyPr lIns="90000" tIns="45000" rIns="90000" bIns="45000" anchor="ctr">
+              <a:noAutofit/>
+            </a:bodyPr>
+            <a:lstStyle/>
+            <a:p>
+              <a:pPr defTabSz="914400">
+                <a:lnSpc>
+                  <a:spcPct val="100000"/>
+                </a:lnSpc>
+                <a:tabLst>
+                  <a:tab pos="0" algn="l"/>
+                </a:tabLst>
+              </a:pPr>
+              <a:r>
+                <a:rPr lang="en-US" sz="1150" b="0" i="1" u="none" strike="noStrike" dirty="0" err="1">
+                  <a:solidFill>
+                    <a:srgbClr val="5A6B7B"/>
+                  </a:solidFill>
+                  <a:effectLst/>
+                  <a:uFillTx/>
+                  <a:latin typeface="Calibri"/>
+                  <a:ea typeface="Calibri"/>
+                </a:rPr>
+                <a:t>IUPred</a:t>
+              </a:r>
+              <a:r>
+                <a:rPr lang="en-US" sz="1150" b="0" i="1" u="none" strike="noStrike" dirty="0">
+                  <a:solidFill>
+                    <a:srgbClr val="5A6B7B"/>
+                  </a:solidFill>
+                  <a:effectLst/>
+                  <a:uFillTx/>
+                  <a:latin typeface="Calibri"/>
+                  <a:ea typeface="Calibri"/>
+                </a:rPr>
+                <a:t> disorder profile: 61.5% disordered (red curve above 0.5). Only the C-terminal domain (aa 230–252) folds; the KEN box, FGF motif and Ser209 all sit in disordered regions.</a:t>
+              </a:r>
+              <a:endParaRPr lang="en-US" sz="1150" b="0" u="none" strike="noStrike" dirty="0">
+                <a:solidFill>
+                  <a:srgbClr val="000000"/>
                 </a:solidFill>
                 <a:effectLst/>
                 <a:uFillTx/>
-                <a:latin typeface="Calibri"/>
-                <a:ea typeface="Calibri"/>
-              </a:rPr>
-              <a:t>IUPred</a:t>
-            </a:r>
-            <a:r>
-              <a:rPr lang="en-US" sz="1150" b="0" i="1" u="none" strike="noStrike" dirty="0">
-                <a:solidFill>
-                  <a:srgbClr val="5A6B7B"/>
-                </a:solidFill>
-                <a:effectLst/>
-                <a:uFillTx/>
-                <a:latin typeface="Calibri"/>
-                <a:ea typeface="Calibri"/>
-              </a:rPr>
-              <a:t> disorder profile: 61.5% disordered (red curve above 0.5). Only the C-terminal domain (aa 230–252) folds; the KEN box, FGF motif and Ser209 all sit in disordered regions.</a:t>
-            </a:r>
-            <a:endParaRPr lang="en-US" sz="1150" b="0" u="none" strike="noStrike" dirty="0">
-              <a:solidFill>
-                <a:srgbClr val="000000"/>
-              </a:solidFill>
-              <a:effectLst/>
-              <a:uFillTx/>
-              <a:latin typeface="Arial"/>
-            </a:endParaRPr>
-          </a:p>
-        </p:txBody>
-      </p:sp>
+                <a:latin typeface="Arial"/>
+              </a:endParaRPr>
+            </a:p>
+          </p:txBody>
+        </p:sp>
+      </p:grpSp>
       <p:sp>
         <p:nvSpPr>
           <p:cNvPr id="55" name="a_key"/>
@@ -15632,7 +19808,7 @@
         </p:nvSpPr>
         <p:spPr>
           <a:xfrm>
-            <a:off x="548640" y="6327720"/>
+            <a:off x="534960" y="6098040"/>
             <a:ext cx="11091240" cy="411120"/>
           </a:xfrm>
           <a:prstGeom prst="roundRect">
@@ -15735,7 +19911,7 @@
                             </p:stCondLst>
                             <p:childTnLst>
                               <p:par>
-                                <p:cTn id="5" presetID="10" presetClass="entr" fill="hold" nodeType="clickEffect">
+                                <p:cTn id="5" presetID="10" presetClass="entr" presetSubtype="0" fill="hold" nodeType="clickEffect">
                                   <p:stCondLst>
                                     <p:cond delay="0"/>
                                   </p:stCondLst>
@@ -15748,7 +19924,7 @@
                                           </p:stCondLst>
                                         </p:cTn>
                                         <p:tgtEl>
-                                          <p:spTgt spid="51"/>
+                                          <p:spTgt spid="2"/>
                                         </p:tgtEl>
                                         <p:attrNameLst>
                                           <p:attrName>style.visibility</p:attrName>
@@ -15759,10 +19935,10 @@
                                       </p:to>
                                     </p:set>
                                     <p:animEffect transition="in" filter="fade">
-                                      <p:cBhvr additive="repl">
+                                      <p:cBhvr>
                                         <p:cTn id="7" dur="500"/>
                                         <p:tgtEl>
-                                          <p:spTgt spid="51"/>
+                                          <p:spTgt spid="2"/>
                                         </p:tgtEl>
                                       </p:cBhvr>
                                     </p:animEffect>
@@ -15788,7 +19964,7 @@
                             </p:stCondLst>
                             <p:childTnLst>
                               <p:par>
-                                <p:cTn id="10" presetID="10" presetClass="entr" fill="hold" nodeType="clickEffect">
+                                <p:cTn id="10" presetID="10" presetClass="entr" presetSubtype="0" fill="hold" nodeType="clickEffect">
                                   <p:stCondLst>
                                     <p:cond delay="0"/>
                                   </p:stCondLst>
@@ -15801,7 +19977,7 @@
                                           </p:stCondLst>
                                         </p:cTn>
                                         <p:tgtEl>
-                                          <p:spTgt spid="53"/>
+                                          <p:spTgt spid="3"/>
                                         </p:tgtEl>
                                         <p:attrNameLst>
                                           <p:attrName>style.visibility</p:attrName>
@@ -15812,10 +19988,10 @@
                                       </p:to>
                                     </p:set>
                                     <p:animEffect transition="in" filter="fade">
-                                      <p:cBhvr additive="repl">
+                                      <p:cBhvr>
                                         <p:cTn id="12" dur="500"/>
                                         <p:tgtEl>
-                                          <p:spTgt spid="53"/>
+                                          <p:spTgt spid="3"/>
                                         </p:tgtEl>
                                       </p:cBhvr>
                                     </p:animEffect>

</xml_diff>